<commit_message>
Add backlog-health dashboard with human-in-the-loop review; update agents, eval harness, docs and presentation
- dashboard/: FastAPI backlog-health dashboard + review queue (deployed to Azure App Service F1)
- config/dor_policy.json: externalized DoR policy for quality_rules
- challenge-3-evaluate/run_local_eval.py: local eval harness
- docs/: evaluation, examples, iteration log, results, roadmap
- updated agents, deploy pipeline, tests, requirements and presentation assets
</commit_message>
<xml_diff>
--- a/presentation/AI-Agile-Delivery-Governance-Slides.pptx
+++ b/presentation/AI-Agile-Delivery-Governance-Slides.pptx
@@ -17,9 +17,11 @@
     <p:sldId id="265" r:id="rId11"/>
     <p:sldId id="266" r:id="rId12"/>
     <p:sldId id="267" r:id="rId13"/>
+    <p:sldId id="268" r:id="rId14"/>
+    <p:sldId id="269" r:id="rId15"/>
   </p:sldIdLst>
   <p:notesMasterIdLst>
-    <p:notesMasterId r:id="rId14"/>
+    <p:notesMasterId r:id="rId16"/>
   </p:notesMasterIdLst>
   <p:sldSz cx="12192000" cy="6858000"/>
   <p:notesSz cx="6858000" cy="12192000"/>
@@ -116,283 +118,6 @@
     </a:lvl9pPr>
   </p:defaultTextStyle>
 </p:presentation>
-</file>
-
-<file path=ppt/charts/chart1.xml><?xml version="1.0" encoding="utf-8"?>
-<c:chartSpace xmlns:c="http://schemas.openxmlformats.org/drawingml/2006/chart" xmlns:a="http://schemas.openxmlformats.org/drawingml/2006/main" xmlns:r="http://schemas.openxmlformats.org/officeDocument/2006/relationships">
-  <c:date1904 val="0"/>
-  <c:roundedCorners val="1"/>
-  <c:chart>
-    <c:autoTitleDeleted val="1"/>
-    <c:plotArea>
-      <c:layout/>
-      <c:barChart>
-        <c:barDir val="col"/>
-        <c:grouping val="clustered"/>
-        <c:varyColors val="0"/>
-        <c:ser>
-          <c:idx val="0"/>
-          <c:order val="0"/>
-          <c:tx>
-            <c:strRef>
-              <c:f>Sheet1!$B$1</c:f>
-              <c:strCache>
-                <c:ptCount val="1"/>
-                <c:pt idx="0">
-                  <c:v>Governance Agent</c:v>
-                </c:pt>
-              </c:strCache>
-            </c:strRef>
-          </c:tx>
-          <c:spPr>
-            <a:solidFill>
-              <a:srgbClr val="12A47E"/>
-            </a:solidFill>
-            <a:effectLst/>
-          </c:spPr>
-          <c:invertIfNegative val="0"/>
-          <c:dLbls>
-            <c:numFmt formatCode="0&quot;%&quot;" sourceLinked="0"/>
-            <c:txPr>
-              <a:bodyPr/>
-              <a:lstStyle/>
-              <a:p>
-                <a:pPr>
-                  <a:defRPr b="0" i="0" strike="noStrike" sz="1300" u="none">
-                    <a:solidFill>
-                      <a:srgbClr val="1E293B"/>
-                    </a:solidFill>
-                    <a:latin typeface="Arial"/>
-                  </a:defRPr>
-                </a:pPr>
-              </a:p>
-            </c:txPr>
-            <c:showLegendKey val="0"/>
-            <c:showVal val="1"/>
-            <c:showCatName val="0"/>
-            <c:showSerName val="0"/>
-            <c:showPercent val="0"/>
-            <c:showBubbleSize val="0"/>
-            <c:showLeaderLines val="0"/>
-          </c:dLbls>
-          <c:dPt>
-            <c:idx val="0"/>
-            <c:invertIfNegative val="0"/>
-            <c:bubble3D val="0"/>
-            <c:spPr>
-              <a:solidFill>
-                <a:srgbClr val="12A47E"/>
-              </a:solidFill>
-              <a:effectLst/>
-            </c:spPr>
-          </c:dPt>
-          <c:dPt>
-            <c:idx val="1"/>
-            <c:invertIfNegative val="0"/>
-            <c:bubble3D val="0"/>
-            <c:spPr>
-              <a:solidFill>
-                <a:srgbClr val="12A47E"/>
-              </a:solidFill>
-              <a:effectLst/>
-            </c:spPr>
-          </c:dPt>
-          <c:dPt>
-            <c:idx val="2"/>
-            <c:invertIfNegative val="0"/>
-            <c:bubble3D val="0"/>
-            <c:spPr>
-              <a:solidFill>
-                <a:srgbClr val="12A47E"/>
-              </a:solidFill>
-              <a:effectLst/>
-            </c:spPr>
-          </c:dPt>
-          <c:cat>
-            <c:multiLvlStrRef>
-              <c:f>Sheet1!$A$2:$A$4</c:f>
-              <c:multiLvlStrCache>
-                <c:ptCount val="3"/>
-                <c:lvl>
-                  <c:pt idx="0">
-                    <c:v>Issue precision</c:v>
-                  </c:pt>
-                  <c:pt idx="1">
-                    <c:v>Issue recall</c:v>
-                  </c:pt>
-                  <c:pt idx="2">
-                    <c:v>Gate accuracy</c:v>
-                  </c:pt>
-                </c:lvl>
-              </c:multiLvlStrCache>
-            </c:multiLvlStrRef>
-          </c:cat>
-          <c:val>
-            <c:numRef>
-              <c:f>Sheet1!$B$2:$B$4</c:f>
-              <c:numCache>
-                <c:formatCode>General</c:formatCode>
-                <c:ptCount val="3"/>
-                <c:pt idx="0">
-                  <c:v>91</c:v>
-                </c:pt>
-                <c:pt idx="1">
-                  <c:v>98</c:v>
-                </c:pt>
-                <c:pt idx="2">
-                  <c:v>93</c:v>
-                </c:pt>
-              </c:numCache>
-            </c:numRef>
-          </c:val>
-        </c:ser>
-        <c:dLbls>
-          <c:numFmt formatCode="0&quot;%&quot;" sourceLinked="0"/>
-          <c:txPr>
-            <a:bodyPr/>
-            <a:lstStyle/>
-            <a:p>
-              <a:pPr>
-                <a:defRPr b="0" i="0" strike="noStrike" sz="1300" u="none">
-                  <a:solidFill>
-                    <a:srgbClr val="1E293B"/>
-                  </a:solidFill>
-                  <a:latin typeface="Arial"/>
-                </a:defRPr>
-              </a:pPr>
-            </a:p>
-          </c:txPr>
-          <c:showLegendKey val="0"/>
-          <c:showVal val="1"/>
-          <c:showCatName val="0"/>
-          <c:showSerName val="0"/>
-          <c:showPercent val="0"/>
-          <c:showBubbleSize val="0"/>
-          <c:showLeaderLines val="0"/>
-        </c:dLbls>
-        <c:gapWidth val="150"/>
-        <c:overlap val="0"/>
-        <c:axId val="2094734554"/>
-        <c:axId val="2094734552"/>
-        <c:axId val="2094734556"/>
-      </c:barChart>
-      <c:catAx>
-        <c:axId val="2094734554"/>
-        <c:scaling>
-          <c:orientation val="minMax"/>
-        </c:scaling>
-        <c:delete val="0"/>
-        <c:axPos val="b"/>
-        <c:numFmt formatCode="General" sourceLinked="1"/>
-        <c:majorTickMark val="out"/>
-        <c:minorTickMark val="none"/>
-        <c:tickLblPos val="low"/>
-        <c:spPr>
-          <a:ln w="12700" cap="flat">
-            <a:solidFill>
-              <a:srgbClr val="888888"/>
-            </a:solidFill>
-            <a:prstDash val="solid"/>
-            <a:round/>
-          </a:ln>
-        </c:spPr>
-        <c:txPr>
-          <a:bodyPr/>
-          <a:lstStyle/>
-          <a:p>
-            <a:pPr>
-              <a:defRPr sz="1200" b="0" i="0" u="none" strike="noStrike">
-                <a:solidFill>
-                  <a:srgbClr val="1E293B"/>
-                </a:solidFill>
-                <a:latin typeface="Arial"/>
-              </a:defRPr>
-            </a:pPr>
-            <a:endParaRPr lang="en-US"/>
-          </a:p>
-        </c:txPr>
-        <c:crossAx val="2094734552"/>
-        <c:crosses val="autoZero"/>
-        <c:auto val="1"/>
-        <c:lblAlgn val="ctr"/>
-        <c:noMultiLvlLbl val="1"/>
-      </c:catAx>
-      <c:valAx>
-        <c:axId val="2094734552"/>
-        <c:scaling>
-          <c:orientation val="minMax"/>
-          <c:max val="100"/>
-          <c:min val="0"/>
-        </c:scaling>
-        <c:delete val="0"/>
-        <c:axPos val="l"/>
-        <c:majorGridlines>
-          <c:spPr>
-            <a:ln w="6350" cap="flat">
-              <a:solidFill>
-                <a:srgbClr val="E2E8F0"/>
-              </a:solidFill>
-              <a:prstDash val="solid"/>
-              <a:round/>
-            </a:ln>
-          </c:spPr>
-        </c:majorGridlines>
-        <c:numFmt formatCode="0&quot;%&quot;" sourceLinked="0"/>
-        <c:majorTickMark val="out"/>
-        <c:minorTickMark val="none"/>
-        <c:tickLblPos val="nextTo"/>
-        <c:spPr>
-          <a:ln w="12700" cap="flat">
-            <a:solidFill>
-              <a:srgbClr val="888888"/>
-            </a:solidFill>
-            <a:prstDash val="solid"/>
-            <a:round/>
-          </a:ln>
-        </c:spPr>
-        <c:txPr>
-          <a:bodyPr/>
-          <a:lstStyle/>
-          <a:p>
-            <a:pPr>
-              <a:defRPr sz="1000" b="0" i="0" u="none" strike="noStrike">
-                <a:solidFill>
-                  <a:srgbClr val="5B6B68"/>
-                </a:solidFill>
-                <a:latin typeface="Arial"/>
-              </a:defRPr>
-            </a:pPr>
-            <a:endParaRPr lang="en-US"/>
-          </a:p>
-        </c:txPr>
-        <c:crossAx val="2094734554"/>
-        <c:crosses val="autoZero"/>
-        <c:crossBetween val="between"/>
-      </c:valAx>
-      <c:spPr>
-        <a:noFill/>
-        <a:ln>
-          <a:noFill/>
-        </a:ln>
-        <a:effectLst/>
-      </c:spPr>
-    </c:plotArea>
-    <c:plotVisOnly val="1"/>
-    <c:dispBlanksAs val="span"/>
-  </c:chart>
-  <c:spPr>
-    <a:solidFill>
-      <a:srgbClr val="FFFFFF"/>
-    </a:solidFill>
-    <a:ln>
-      <a:noFill/>
-    </a:ln>
-    <a:effectLst/>
-  </c:spPr>
-  <c:externalData r:id="rId1">
-    <c:autoUpdate val="0"/>
-  </c:externalData>
-</c:chartSpace>
 </file>
 
 <file path=ppt/notesMasters/notesMaster1.xml><?xml version="1.0" encoding="utf-8"?>
@@ -878,7 +603,7 @@
           <a:p>
             <a:r>
               <a:rPr lang="en-US" dirty="0"/>
-              <a:t>On the golden set the agent catches seeded problems with high precision/recall and matches the human gate labels most of the time. Honest framing: these are offline-harness numbers.</a:t>
+              <a:t>Evaluation has three pillars. Correctness — does the gate decide right — from the offline harness against ground truth: precision 0.91, recall 0.98, gate accuracy 0.93. Output quality from the Foundry LLM-as-judge: coherence 4.7, intent 4.9, fluency 4. And a clean safety sweep across every dimension. Correctness offline, quality and safety on Foundry.</a:t>
             </a:r>
             <a:endParaRPr lang="en-US" dirty="0"/>
           </a:p>
@@ -966,7 +691,7 @@
           <a:p>
             <a:r>
               <a:rPr lang="en-US" dirty="0"/>
-              <a:t>Faster planning, a measurable gate, and a governance system that is itself governed. You trust the output because it is measured.</a:t>
+              <a:t>The gate is three-way: pass, reject, and review. Borderline scores and hard blockers go to a human. The decision becomes a new labelled example, so the gate improves on exactly the hard cases.</a:t>
             </a:r>
             <a:endParaRPr lang="en-US" dirty="0"/>
           </a:p>
@@ -1054,7 +779,7 @@
           <a:p>
             <a:r>
               <a:rPr lang="en-US" dirty="0"/>
-              <a:t>Close cleanly: governed delivery, from requirement to ready. Thank you. Don't add more.</a:t>
+              <a:t>Because every verdict is structured and traced, aggregating them gives a backlog-health view: pass-rate, recurring INVEST failures, top issues, and the human review queue with ageing. This is the reviewer's suggested next step, built.</a:t>
             </a:r>
             <a:endParaRPr lang="en-US" dirty="0"/>
           </a:p>
@@ -1078,6 +803,182 @@
             <a:fld id="{F7021451-1387-4CA6-816F-3879F97B5CBC}" type="slidenum">
               <a:rPr lang="en-US"/>
               <a:t>12</a:t>
+            </a:fld>
+            <a:endParaRPr lang="en-US"/>
+          </a:p>
+        </p:txBody>
+      </p:sp>
+    </p:spTree>
+    <p:extLst>
+      <p:ext uri="{BB962C8B-B14F-4D97-AF65-F5344CB8AC3E}">
+        <p14:creationId xmlns:p14="http://schemas.microsoft.com/office/powerpoint/2010/main" val="1024086991"/>
+      </p:ext>
+    </p:extLst>
+  </p:cSld>
+  <p:clrMapOvr>
+    <a:masterClrMapping/>
+  </p:clrMapOvr>
+</p:notes>
+</file>
+
+<file path=ppt/notesSlides/notesSlide13.xml><?xml version="1.0" encoding="utf-8"?>
+<p:notes xmlns:a="http://schemas.openxmlformats.org/drawingml/2006/main" xmlns:r="http://schemas.openxmlformats.org/officeDocument/2006/relationships" xmlns:p="http://schemas.openxmlformats.org/presentationml/2006/main">
+  <p:cSld>
+    <p:spTree>
+      <p:nvGrpSpPr>
+        <p:cNvPr id="1" name=""/>
+        <p:cNvGrpSpPr/>
+        <p:nvPr/>
+      </p:nvGrpSpPr>
+      <p:grpSpPr>
+        <a:xfrm>
+          <a:off x="0" y="0"/>
+          <a:ext cx="0" cy="0"/>
+          <a:chOff x="0" y="0"/>
+          <a:chExt cx="0" cy="0"/>
+        </a:xfrm>
+      </p:grpSpPr>
+      <p:sp>
+        <p:nvSpPr>
+          <p:cNvPr id="2" name="Slide Image Placeholder 1"/>
+          <p:cNvSpPr>
+            <a:spLocks noGrp="1" noRot="1" noChangeAspect="1"/>
+          </p:cNvSpPr>
+          <p:nvPr>
+            <p:ph type="sldImg"/>
+          </p:nvPr>
+        </p:nvSpPr>
+        <p:spPr/>
+      </p:sp>
+      <p:sp>
+        <p:nvSpPr>
+          <p:cNvPr id="3" name="Notes Placeholder 2"/>
+          <p:cNvSpPr>
+            <a:spLocks noGrp="1"/>
+          </p:cNvSpPr>
+          <p:nvPr>
+            <p:ph type="body" idx="1"/>
+          </p:nvPr>
+        </p:nvSpPr>
+        <p:spPr/>
+        <p:txBody>
+          <a:bodyPr/>
+          <a:lstStyle/>
+          <a:p>
+            <a:r>
+              <a:rPr lang="en-US" dirty="0"/>
+              <a:t>Faster planning, a measurable gate, and a governance system that is itself governed. You trust the output because it is measured.</a:t>
+            </a:r>
+            <a:endParaRPr lang="en-US" dirty="0"/>
+          </a:p>
+        </p:txBody>
+      </p:sp>
+      <p:sp>
+        <p:nvSpPr>
+          <p:cNvPr id="4" name="Slide Number Placeholder 3"/>
+          <p:cNvSpPr>
+            <a:spLocks noGrp="1"/>
+          </p:cNvSpPr>
+          <p:nvPr>
+            <p:ph type="sldNum" sz="quarter" idx="10"/>
+          </p:nvPr>
+        </p:nvSpPr>
+        <p:spPr/>
+        <p:txBody>
+          <a:bodyPr/>
+          <a:lstStyle/>
+          <a:p>
+            <a:fld id="{F7021451-1387-4CA6-816F-3879F97B5CBC}" type="slidenum">
+              <a:rPr lang="en-US"/>
+              <a:t>13</a:t>
+            </a:fld>
+            <a:endParaRPr lang="en-US"/>
+          </a:p>
+        </p:txBody>
+      </p:sp>
+    </p:spTree>
+    <p:extLst>
+      <p:ext uri="{BB962C8B-B14F-4D97-AF65-F5344CB8AC3E}">
+        <p14:creationId xmlns:p14="http://schemas.microsoft.com/office/powerpoint/2010/main" val="1024086991"/>
+      </p:ext>
+    </p:extLst>
+  </p:cSld>
+  <p:clrMapOvr>
+    <a:masterClrMapping/>
+  </p:clrMapOvr>
+</p:notes>
+</file>
+
+<file path=ppt/notesSlides/notesSlide14.xml><?xml version="1.0" encoding="utf-8"?>
+<p:notes xmlns:a="http://schemas.openxmlformats.org/drawingml/2006/main" xmlns:r="http://schemas.openxmlformats.org/officeDocument/2006/relationships" xmlns:p="http://schemas.openxmlformats.org/presentationml/2006/main">
+  <p:cSld>
+    <p:spTree>
+      <p:nvGrpSpPr>
+        <p:cNvPr id="1" name=""/>
+        <p:cNvGrpSpPr/>
+        <p:nvPr/>
+      </p:nvGrpSpPr>
+      <p:grpSpPr>
+        <a:xfrm>
+          <a:off x="0" y="0"/>
+          <a:ext cx="0" cy="0"/>
+          <a:chOff x="0" y="0"/>
+          <a:chExt cx="0" cy="0"/>
+        </a:xfrm>
+      </p:grpSpPr>
+      <p:sp>
+        <p:nvSpPr>
+          <p:cNvPr id="2" name="Slide Image Placeholder 1"/>
+          <p:cNvSpPr>
+            <a:spLocks noGrp="1" noRot="1" noChangeAspect="1"/>
+          </p:cNvSpPr>
+          <p:nvPr>
+            <p:ph type="sldImg"/>
+          </p:nvPr>
+        </p:nvSpPr>
+        <p:spPr/>
+      </p:sp>
+      <p:sp>
+        <p:nvSpPr>
+          <p:cNvPr id="3" name="Notes Placeholder 2"/>
+          <p:cNvSpPr>
+            <a:spLocks noGrp="1"/>
+          </p:cNvSpPr>
+          <p:nvPr>
+            <p:ph type="body" idx="1"/>
+          </p:nvPr>
+        </p:nvSpPr>
+        <p:spPr/>
+        <p:txBody>
+          <a:bodyPr/>
+          <a:lstStyle/>
+          <a:p>
+            <a:r>
+              <a:rPr lang="en-US" dirty="0"/>
+              <a:t>Close cleanly: governed delivery, from requirement to ready. Thank you. Don't add more.</a:t>
+            </a:r>
+            <a:endParaRPr lang="en-US" dirty="0"/>
+          </a:p>
+        </p:txBody>
+      </p:sp>
+      <p:sp>
+        <p:nvSpPr>
+          <p:cNvPr id="4" name="Slide Number Placeholder 3"/>
+          <p:cNvSpPr>
+            <a:spLocks noGrp="1"/>
+          </p:cNvSpPr>
+          <p:nvPr>
+            <p:ph type="sldNum" sz="quarter" idx="10"/>
+          </p:nvPr>
+        </p:nvSpPr>
+        <p:spPr/>
+        <p:txBody>
+          <a:bodyPr/>
+          <a:lstStyle/>
+          <a:p>
+            <a:fld id="{F7021451-1387-4CA6-816F-3879F97B5CBC}" type="slidenum">
+              <a:rPr lang="en-US"/>
+              <a:t>14</a:t>
             </a:fld>
             <a:endParaRPr lang="en-US"/>
           </a:p>
@@ -2540,7 +2441,7 @@
                 <a:ea typeface="Calibri" pitchFamily="34" charset="-122"/>
                 <a:cs typeface="Calibri" pitchFamily="34" charset="-120"/>
               </a:rPr>
-              <a:t>RESULTS</a:t>
+              <a:t>EVALUATION</a:t>
             </a:r>
             <a:endParaRPr lang="en-US" sz="1200" dirty="0"/>
           </a:p>
@@ -2579,46 +2480,30 @@
                 <a:ea typeface="Cambria" pitchFamily="34" charset="-122"/>
                 <a:cs typeface="Cambria" pitchFamily="34" charset="-120"/>
               </a:rPr>
-              <a:t>Measured, not guessed</a:t>
+              <a:t>Measured three ways</a:t>
             </a:r>
             <a:endParaRPr lang="en-US" sz="3200" dirty="0"/>
           </a:p>
         </p:txBody>
       </p:sp>
-      <p:graphicFrame>
-        <p:nvGraphicFramePr>
-          <p:cNvPr id="4" name="Chart 0" descr=""/>
-          <p:cNvGraphicFramePr/>
-          <p:nvPr/>
-        </p:nvGraphicFramePr>
-        <p:xfrm>
-          <a:off x="640080" y="2148840"/>
-          <a:ext cx="6675120" cy="3749040"/>
-        </p:xfrm>
-        <a:graphic xmlns:a="http://schemas.openxmlformats.org/drawingml/2006/main">
-          <a:graphicData uri="http://schemas.openxmlformats.org/drawingml/2006/chart">
-            <c:chart xmlns:c="http://schemas.openxmlformats.org/drawingml/2006/chart" r:id="rId1"/>
-          </a:graphicData>
-        </a:graphic>
-      </p:graphicFrame>
-      <p:sp>
-        <p:nvSpPr>
-          <p:cNvPr id="5" name="Shape 2"/>
-          <p:cNvSpPr/>
-          <p:nvPr/>
-        </p:nvSpPr>
-        <p:spPr>
-          <a:xfrm>
-            <a:off x="7680960" y="2148840"/>
-            <a:ext cx="3840480" cy="1737360"/>
+      <p:sp>
+        <p:nvSpPr>
+          <p:cNvPr id="4" name="Shape 2"/>
+          <p:cNvSpPr/>
+          <p:nvPr/>
+        </p:nvSpPr>
+        <p:spPr>
+          <a:xfrm>
+            <a:off x="640080" y="2057400"/>
+            <a:ext cx="3520440" cy="3977640"/>
           </a:xfrm>
           <a:prstGeom prst="roundRect">
             <a:avLst>
-              <a:gd name="adj" fmla="val 5263"/>
+              <a:gd name="adj" fmla="val 2597"/>
             </a:avLst>
           </a:prstGeom>
           <a:solidFill>
-            <a:srgbClr val="E7F4EF"/>
+            <a:srgbClr val="F0F7F5"/>
           </a:solidFill>
           <a:ln/>
           <a:effectLst>
@@ -2632,30 +2517,108 @@
       </p:sp>
       <p:sp>
         <p:nvSpPr>
-          <p:cNvPr id="6" name="Text 3"/>
-          <p:cNvSpPr/>
-          <p:nvPr/>
-        </p:nvSpPr>
-        <p:spPr>
-          <a:xfrm>
-            <a:off x="7680960" y="2377440"/>
-            <a:ext cx="3840480" cy="822960"/>
-          </a:xfrm>
-          <a:prstGeom prst="rect">
-            <a:avLst/>
-          </a:prstGeom>
-          <a:noFill/>
-          <a:ln/>
-        </p:spPr>
-        <p:txBody>
-          <a:bodyPr wrap="square" lIns="0" tIns="0" rIns="0" bIns="0" rtlCol="0" anchor="ctr"/>
-          <a:lstStyle/>
-          <a:p>
-            <a:pPr algn="ctr" indent="0" marL="0">
-              <a:buNone/>
-            </a:pPr>
-            <a:r>
-              <a:rPr lang="en-US" sz="4800" b="1" dirty="0">
+          <p:cNvPr id="5" name="Text 3"/>
+          <p:cNvSpPr/>
+          <p:nvPr/>
+        </p:nvSpPr>
+        <p:spPr>
+          <a:xfrm>
+            <a:off x="868680" y="2286000"/>
+            <a:ext cx="3108960" cy="320040"/>
+          </a:xfrm>
+          <a:prstGeom prst="rect">
+            <a:avLst/>
+          </a:prstGeom>
+          <a:noFill/>
+          <a:ln/>
+        </p:spPr>
+        <p:txBody>
+          <a:bodyPr wrap="square" lIns="0" tIns="0" rIns="0" bIns="0" rtlCol="0" anchor="ctr"/>
+          <a:lstStyle/>
+          <a:p>
+            <a:pPr indent="0" marL="0">
+              <a:buNone/>
+            </a:pPr>
+            <a:r>
+              <a:rPr lang="en-US" sz="1200" b="1" spc="200" kern="0" dirty="0">
+                <a:solidFill>
+                  <a:srgbClr val="12A47E"/>
+                </a:solidFill>
+                <a:latin typeface="Calibri" pitchFamily="34" charset="0"/>
+                <a:ea typeface="Calibri" pitchFamily="34" charset="-122"/>
+                <a:cs typeface="Calibri" pitchFamily="34" charset="-120"/>
+              </a:rPr>
+              <a:t>CORRECTNESS</a:t>
+            </a:r>
+            <a:endParaRPr lang="en-US" sz="1200" dirty="0"/>
+          </a:p>
+        </p:txBody>
+      </p:sp>
+      <p:sp>
+        <p:nvSpPr>
+          <p:cNvPr id="6" name="Text 4"/>
+          <p:cNvSpPr/>
+          <p:nvPr/>
+        </p:nvSpPr>
+        <p:spPr>
+          <a:xfrm>
+            <a:off x="868680" y="2578608"/>
+            <a:ext cx="3108960" cy="320040"/>
+          </a:xfrm>
+          <a:prstGeom prst="rect">
+            <a:avLst/>
+          </a:prstGeom>
+          <a:noFill/>
+          <a:ln/>
+        </p:spPr>
+        <p:txBody>
+          <a:bodyPr wrap="square" lIns="0" tIns="0" rIns="0" bIns="0" rtlCol="0" anchor="ctr"/>
+          <a:lstStyle/>
+          <a:p>
+            <a:pPr indent="0" marL="0">
+              <a:buNone/>
+            </a:pPr>
+            <a:r>
+              <a:rPr lang="en-US" sz="1200" i="1" dirty="0">
+                <a:solidFill>
+                  <a:srgbClr val="5B6B68"/>
+                </a:solidFill>
+                <a:latin typeface="Calibri" pitchFamily="34" charset="0"/>
+                <a:ea typeface="Calibri" pitchFamily="34" charset="-122"/>
+                <a:cs typeface="Calibri" pitchFamily="34" charset="-120"/>
+              </a:rPr>
+              <a:t>does the gate decide right?</a:t>
+            </a:r>
+            <a:endParaRPr lang="en-US" sz="1200" dirty="0"/>
+          </a:p>
+        </p:txBody>
+      </p:sp>
+      <p:sp>
+        <p:nvSpPr>
+          <p:cNvPr id="7" name="Text 5"/>
+          <p:cNvSpPr/>
+          <p:nvPr/>
+        </p:nvSpPr>
+        <p:spPr>
+          <a:xfrm>
+            <a:off x="868680" y="3063240"/>
+            <a:ext cx="1097280" cy="548640"/>
+          </a:xfrm>
+          <a:prstGeom prst="rect">
+            <a:avLst/>
+          </a:prstGeom>
+          <a:noFill/>
+          <a:ln/>
+        </p:spPr>
+        <p:txBody>
+          <a:bodyPr wrap="square" lIns="0" tIns="0" rIns="0" bIns="0" rtlCol="0" anchor="ctr"/>
+          <a:lstStyle/>
+          <a:p>
+            <a:pPr indent="0" marL="0">
+              <a:buNone/>
+            </a:pPr>
+            <a:r>
+              <a:rPr lang="en-US" sz="3000" b="1" dirty="0">
                 <a:solidFill>
                   <a:srgbClr val="0F6E56"/>
                 </a:solidFill>
@@ -2663,46 +2626,46 @@
                 <a:ea typeface="Cambria" pitchFamily="34" charset="-122"/>
                 <a:cs typeface="Cambria" pitchFamily="34" charset="-120"/>
               </a:rPr>
-              <a:t>~50%</a:t>
-            </a:r>
-            <a:endParaRPr lang="en-US" sz="4800" dirty="0"/>
-          </a:p>
-        </p:txBody>
-      </p:sp>
-      <p:sp>
-        <p:nvSpPr>
-          <p:cNvPr id="7" name="Text 4"/>
-          <p:cNvSpPr/>
-          <p:nvPr/>
-        </p:nvSpPr>
-        <p:spPr>
-          <a:xfrm>
-            <a:off x="7680960" y="3246120"/>
-            <a:ext cx="3840480" cy="502920"/>
-          </a:xfrm>
-          <a:prstGeom prst="rect">
-            <a:avLst/>
-          </a:prstGeom>
-          <a:noFill/>
-          <a:ln/>
-        </p:spPr>
-        <p:txBody>
-          <a:bodyPr wrap="square" lIns="0" tIns="0" rIns="0" bIns="0" rtlCol="0" anchor="ctr"/>
-          <a:lstStyle/>
-          <a:p>
-            <a:pPr algn="ctr" indent="0" marL="0">
+              <a:t>0.91</a:t>
+            </a:r>
+            <a:endParaRPr lang="en-US" sz="3000" dirty="0"/>
+          </a:p>
+        </p:txBody>
+      </p:sp>
+      <p:sp>
+        <p:nvSpPr>
+          <p:cNvPr id="8" name="Text 6"/>
+          <p:cNvSpPr/>
+          <p:nvPr/>
+        </p:nvSpPr>
+        <p:spPr>
+          <a:xfrm>
+            <a:off x="1965960" y="3172968"/>
+            <a:ext cx="2103120" cy="365760"/>
+          </a:xfrm>
+          <a:prstGeom prst="rect">
+            <a:avLst/>
+          </a:prstGeom>
+          <a:noFill/>
+          <a:ln/>
+        </p:spPr>
+        <p:txBody>
+          <a:bodyPr wrap="square" lIns="0" tIns="0" rIns="0" bIns="0" rtlCol="0" anchor="ctr"/>
+          <a:lstStyle/>
+          <a:p>
+            <a:pPr indent="0" marL="0">
               <a:buNone/>
             </a:pPr>
             <a:r>
               <a:rPr lang="en-US" sz="1300" dirty="0">
                 <a:solidFill>
-                  <a:srgbClr val="5B6B68"/>
+                  <a:srgbClr val="1E293B"/>
                 </a:solidFill>
                 <a:latin typeface="Calibri" pitchFamily="34" charset="0"/>
                 <a:ea typeface="Calibri" pitchFamily="34" charset="-122"/>
                 <a:cs typeface="Calibri" pitchFamily="34" charset="-120"/>
               </a:rPr>
-              <a:t>gate pass-rate on the sample backlog</a:t>
+              <a:t>Issue precision</a:t>
             </a:r>
             <a:endParaRPr lang="en-US" sz="1300" dirty="0"/>
           </a:p>
@@ -2710,18 +2673,213 @@
       </p:sp>
       <p:sp>
         <p:nvSpPr>
-          <p:cNvPr id="8" name="Shape 5"/>
-          <p:cNvSpPr/>
-          <p:nvPr/>
-        </p:nvSpPr>
-        <p:spPr>
-          <a:xfrm>
-            <a:off x="7680960" y="4114800"/>
-            <a:ext cx="3840480" cy="1783080"/>
+          <p:cNvPr id="9" name="Text 7"/>
+          <p:cNvSpPr/>
+          <p:nvPr/>
+        </p:nvSpPr>
+        <p:spPr>
+          <a:xfrm>
+            <a:off x="868680" y="3931920"/>
+            <a:ext cx="1097280" cy="548640"/>
+          </a:xfrm>
+          <a:prstGeom prst="rect">
+            <a:avLst/>
+          </a:prstGeom>
+          <a:noFill/>
+          <a:ln/>
+        </p:spPr>
+        <p:txBody>
+          <a:bodyPr wrap="square" lIns="0" tIns="0" rIns="0" bIns="0" rtlCol="0" anchor="ctr"/>
+          <a:lstStyle/>
+          <a:p>
+            <a:pPr indent="0" marL="0">
+              <a:buNone/>
+            </a:pPr>
+            <a:r>
+              <a:rPr lang="en-US" sz="3000" b="1" dirty="0">
+                <a:solidFill>
+                  <a:srgbClr val="0F6E56"/>
+                </a:solidFill>
+                <a:latin typeface="Cambria" pitchFamily="34" charset="0"/>
+                <a:ea typeface="Cambria" pitchFamily="34" charset="-122"/>
+                <a:cs typeface="Cambria" pitchFamily="34" charset="-120"/>
+              </a:rPr>
+              <a:t>0.98</a:t>
+            </a:r>
+            <a:endParaRPr lang="en-US" sz="3000" dirty="0"/>
+          </a:p>
+        </p:txBody>
+      </p:sp>
+      <p:sp>
+        <p:nvSpPr>
+          <p:cNvPr id="10" name="Text 8"/>
+          <p:cNvSpPr/>
+          <p:nvPr/>
+        </p:nvSpPr>
+        <p:spPr>
+          <a:xfrm>
+            <a:off x="1965960" y="4041648"/>
+            <a:ext cx="2103120" cy="365760"/>
+          </a:xfrm>
+          <a:prstGeom prst="rect">
+            <a:avLst/>
+          </a:prstGeom>
+          <a:noFill/>
+          <a:ln/>
+        </p:spPr>
+        <p:txBody>
+          <a:bodyPr wrap="square" lIns="0" tIns="0" rIns="0" bIns="0" rtlCol="0" anchor="ctr"/>
+          <a:lstStyle/>
+          <a:p>
+            <a:pPr indent="0" marL="0">
+              <a:buNone/>
+            </a:pPr>
+            <a:r>
+              <a:rPr lang="en-US" sz="1300" dirty="0">
+                <a:solidFill>
+                  <a:srgbClr val="1E293B"/>
+                </a:solidFill>
+                <a:latin typeface="Calibri" pitchFamily="34" charset="0"/>
+                <a:ea typeface="Calibri" pitchFamily="34" charset="-122"/>
+                <a:cs typeface="Calibri" pitchFamily="34" charset="-120"/>
+              </a:rPr>
+              <a:t>Issue recall</a:t>
+            </a:r>
+            <a:endParaRPr lang="en-US" sz="1300" dirty="0"/>
+          </a:p>
+        </p:txBody>
+      </p:sp>
+      <p:sp>
+        <p:nvSpPr>
+          <p:cNvPr id="11" name="Text 9"/>
+          <p:cNvSpPr/>
+          <p:nvPr/>
+        </p:nvSpPr>
+        <p:spPr>
+          <a:xfrm>
+            <a:off x="868680" y="4800600"/>
+            <a:ext cx="1097280" cy="548640"/>
+          </a:xfrm>
+          <a:prstGeom prst="rect">
+            <a:avLst/>
+          </a:prstGeom>
+          <a:noFill/>
+          <a:ln/>
+        </p:spPr>
+        <p:txBody>
+          <a:bodyPr wrap="square" lIns="0" tIns="0" rIns="0" bIns="0" rtlCol="0" anchor="ctr"/>
+          <a:lstStyle/>
+          <a:p>
+            <a:pPr indent="0" marL="0">
+              <a:buNone/>
+            </a:pPr>
+            <a:r>
+              <a:rPr lang="en-US" sz="3000" b="1" dirty="0">
+                <a:solidFill>
+                  <a:srgbClr val="0F6E56"/>
+                </a:solidFill>
+                <a:latin typeface="Cambria" pitchFamily="34" charset="0"/>
+                <a:ea typeface="Cambria" pitchFamily="34" charset="-122"/>
+                <a:cs typeface="Cambria" pitchFamily="34" charset="-120"/>
+              </a:rPr>
+              <a:t>0.93</a:t>
+            </a:r>
+            <a:endParaRPr lang="en-US" sz="3000" dirty="0"/>
+          </a:p>
+        </p:txBody>
+      </p:sp>
+      <p:sp>
+        <p:nvSpPr>
+          <p:cNvPr id="12" name="Text 10"/>
+          <p:cNvSpPr/>
+          <p:nvPr/>
+        </p:nvSpPr>
+        <p:spPr>
+          <a:xfrm>
+            <a:off x="1965960" y="4910328"/>
+            <a:ext cx="2103120" cy="365760"/>
+          </a:xfrm>
+          <a:prstGeom prst="rect">
+            <a:avLst/>
+          </a:prstGeom>
+          <a:noFill/>
+          <a:ln/>
+        </p:spPr>
+        <p:txBody>
+          <a:bodyPr wrap="square" lIns="0" tIns="0" rIns="0" bIns="0" rtlCol="0" anchor="ctr"/>
+          <a:lstStyle/>
+          <a:p>
+            <a:pPr indent="0" marL="0">
+              <a:buNone/>
+            </a:pPr>
+            <a:r>
+              <a:rPr lang="en-US" sz="1300" dirty="0">
+                <a:solidFill>
+                  <a:srgbClr val="1E293B"/>
+                </a:solidFill>
+                <a:latin typeface="Calibri" pitchFamily="34" charset="0"/>
+                <a:ea typeface="Calibri" pitchFamily="34" charset="-122"/>
+                <a:cs typeface="Calibri" pitchFamily="34" charset="-120"/>
+              </a:rPr>
+              <a:t>Gate accuracy</a:t>
+            </a:r>
+            <a:endParaRPr lang="en-US" sz="1300" dirty="0"/>
+          </a:p>
+        </p:txBody>
+      </p:sp>
+      <p:sp>
+        <p:nvSpPr>
+          <p:cNvPr id="13" name="Text 11"/>
+          <p:cNvSpPr/>
+          <p:nvPr/>
+        </p:nvSpPr>
+        <p:spPr>
+          <a:xfrm>
+            <a:off x="868680" y="5669280"/>
+            <a:ext cx="3108960" cy="274320"/>
+          </a:xfrm>
+          <a:prstGeom prst="rect">
+            <a:avLst/>
+          </a:prstGeom>
+          <a:noFill/>
+          <a:ln/>
+        </p:spPr>
+        <p:txBody>
+          <a:bodyPr wrap="square" lIns="0" tIns="0" rIns="0" bIns="0" rtlCol="0" anchor="ctr"/>
+          <a:lstStyle/>
+          <a:p>
+            <a:pPr indent="0" marL="0">
+              <a:buNone/>
+            </a:pPr>
+            <a:r>
+              <a:rPr lang="en-US" sz="1050" i="1" dirty="0">
+                <a:solidFill>
+                  <a:srgbClr val="5B6B68"/>
+                </a:solidFill>
+                <a:latin typeface="Calibri" pitchFamily="34" charset="0"/>
+                <a:ea typeface="Calibri" pitchFamily="34" charset="-122"/>
+                <a:cs typeface="Calibri" pitchFamily="34" charset="-120"/>
+              </a:rPr>
+              <a:t>offline harness · golden set</a:t>
+            </a:r>
+            <a:endParaRPr lang="en-US" sz="1050" dirty="0"/>
+          </a:p>
+        </p:txBody>
+      </p:sp>
+      <p:sp>
+        <p:nvSpPr>
+          <p:cNvPr id="14" name="Shape 12"/>
+          <p:cNvSpPr/>
+          <p:nvPr/>
+        </p:nvSpPr>
+        <p:spPr>
+          <a:xfrm>
+            <a:off x="4334256" y="2057400"/>
+            <a:ext cx="3520440" cy="3977640"/>
           </a:xfrm>
           <a:prstGeom prst="roundRect">
             <a:avLst>
-              <a:gd name="adj" fmla="val 5128"/>
+              <a:gd name="adj" fmla="val 2597"/>
             </a:avLst>
           </a:prstGeom>
           <a:solidFill>
@@ -2739,69 +2897,69 @@
       </p:sp>
       <p:sp>
         <p:nvSpPr>
-          <p:cNvPr id="9" name="Text 6"/>
-          <p:cNvSpPr/>
-          <p:nvPr/>
-        </p:nvSpPr>
-        <p:spPr>
-          <a:xfrm>
-            <a:off x="7955280" y="4297680"/>
-            <a:ext cx="3291840" cy="1463040"/>
-          </a:xfrm>
-          <a:prstGeom prst="rect">
-            <a:avLst/>
-          </a:prstGeom>
-          <a:noFill/>
-          <a:ln/>
-        </p:spPr>
-        <p:txBody>
-          <a:bodyPr wrap="square" lIns="0" tIns="0" rIns="0" bIns="0" rtlCol="0" anchor="ctr"/>
-          <a:lstStyle/>
-          <a:p>
-            <a:pPr indent="0" marL="0">
-              <a:buNone/>
-            </a:pPr>
-            <a:r>
-              <a:rPr lang="en-US" sz="1450" dirty="0">
-                <a:solidFill>
-                  <a:srgbClr val="1E293B"/>
+          <p:cNvPr id="15" name="Text 13"/>
+          <p:cNvSpPr/>
+          <p:nvPr/>
+        </p:nvSpPr>
+        <p:spPr>
+          <a:xfrm>
+            <a:off x="4562856" y="2286000"/>
+            <a:ext cx="3108960" cy="320040"/>
+          </a:xfrm>
+          <a:prstGeom prst="rect">
+            <a:avLst/>
+          </a:prstGeom>
+          <a:noFill/>
+          <a:ln/>
+        </p:spPr>
+        <p:txBody>
+          <a:bodyPr wrap="square" lIns="0" tIns="0" rIns="0" bIns="0" rtlCol="0" anchor="ctr"/>
+          <a:lstStyle/>
+          <a:p>
+            <a:pPr indent="0" marL="0">
+              <a:buNone/>
+            </a:pPr>
+            <a:r>
+              <a:rPr lang="en-US" sz="1200" b="1" spc="200" kern="0" dirty="0">
+                <a:solidFill>
+                  <a:srgbClr val="12A47E"/>
                 </a:solidFill>
                 <a:latin typeface="Calibri" pitchFamily="34" charset="0"/>
                 <a:ea typeface="Calibri" pitchFamily="34" charset="-122"/>
                 <a:cs typeface="Calibri" pitchFamily="34" charset="-120"/>
               </a:rPr>
-              <a:t>And where the agent is wrong, the evaluation surfaces exactly which cases to fix.</a:t>
-            </a:r>
-            <a:endParaRPr lang="en-US" sz="1450" dirty="0"/>
-          </a:p>
-        </p:txBody>
-      </p:sp>
-      <p:sp>
-        <p:nvSpPr>
-          <p:cNvPr id="10" name="Text 7"/>
-          <p:cNvSpPr/>
-          <p:nvPr/>
-        </p:nvSpPr>
-        <p:spPr>
-          <a:xfrm>
-            <a:off x="640080" y="6126480"/>
-            <a:ext cx="10881360" cy="365760"/>
-          </a:xfrm>
-          <a:prstGeom prst="rect">
-            <a:avLst/>
-          </a:prstGeom>
-          <a:noFill/>
-          <a:ln/>
-        </p:spPr>
-        <p:txBody>
-          <a:bodyPr wrap="square" lIns="0" tIns="0" rIns="0" bIns="0" rtlCol="0" anchor="ctr"/>
-          <a:lstStyle/>
-          <a:p>
-            <a:pPr indent="0" marL="0">
-              <a:buNone/>
-            </a:pPr>
-            <a:r>
-              <a:rPr lang="en-US" sz="1150" i="1" dirty="0">
+              <a:t>OUTPUT QUALITY</a:t>
+            </a:r>
+            <a:endParaRPr lang="en-US" sz="1200" dirty="0"/>
+          </a:p>
+        </p:txBody>
+      </p:sp>
+      <p:sp>
+        <p:nvSpPr>
+          <p:cNvPr id="16" name="Text 14"/>
+          <p:cNvSpPr/>
+          <p:nvPr/>
+        </p:nvSpPr>
+        <p:spPr>
+          <a:xfrm>
+            <a:off x="4562856" y="2578608"/>
+            <a:ext cx="3108960" cy="320040"/>
+          </a:xfrm>
+          <a:prstGeom prst="rect">
+            <a:avLst/>
+          </a:prstGeom>
+          <a:noFill/>
+          <a:ln/>
+        </p:spPr>
+        <p:txBody>
+          <a:bodyPr wrap="square" lIns="0" tIns="0" rIns="0" bIns="0" rtlCol="0" anchor="ctr"/>
+          <a:lstStyle/>
+          <a:p>
+            <a:pPr indent="0" marL="0">
+              <a:buNone/>
+            </a:pPr>
+            <a:r>
+              <a:rPr lang="en-US" sz="1200" i="1" dirty="0">
                 <a:solidFill>
                   <a:srgbClr val="5B6B68"/>
                 </a:solidFill>
@@ -2809,7 +2967,605 @@
                 <a:ea typeface="Calibri" pitchFamily="34" charset="-122"/>
                 <a:cs typeface="Calibri" pitchFamily="34" charset="-120"/>
               </a:rPr>
-              <a:t>Illustrative scores from the offline evaluation harness over the 15-story golden set.</a:t>
+              <a:t>Foundry LLM-as-judge</a:t>
+            </a:r>
+            <a:endParaRPr lang="en-US" sz="1200" dirty="0"/>
+          </a:p>
+        </p:txBody>
+      </p:sp>
+      <p:sp>
+        <p:nvSpPr>
+          <p:cNvPr id="17" name="Text 15"/>
+          <p:cNvSpPr/>
+          <p:nvPr/>
+        </p:nvSpPr>
+        <p:spPr>
+          <a:xfrm>
+            <a:off x="4562856" y="3063240"/>
+            <a:ext cx="1371600" cy="548640"/>
+          </a:xfrm>
+          <a:prstGeom prst="rect">
+            <a:avLst/>
+          </a:prstGeom>
+          <a:noFill/>
+          <a:ln/>
+        </p:spPr>
+        <p:txBody>
+          <a:bodyPr wrap="square" lIns="0" tIns="0" rIns="0" bIns="0" rtlCol="0" anchor="ctr"/>
+          <a:lstStyle/>
+          <a:p>
+            <a:pPr indent="0" marL="0">
+              <a:buNone/>
+            </a:pPr>
+            <a:r>
+              <a:rPr lang="en-US" sz="3000" b="1" dirty="0">
+                <a:solidFill>
+                  <a:srgbClr val="0F6E56"/>
+                </a:solidFill>
+                <a:latin typeface="Cambria" pitchFamily="34" charset="0"/>
+                <a:ea typeface="Cambria" pitchFamily="34" charset="-122"/>
+                <a:cs typeface="Cambria" pitchFamily="34" charset="-120"/>
+              </a:rPr>
+              <a:t>4.7</a:t>
+            </a:r>
+            <a:pPr indent="0" marL="0">
+              <a:buNone/>
+            </a:pPr>
+            <a:r>
+              <a:rPr lang="en-US" sz="1400" dirty="0">
+                <a:solidFill>
+                  <a:srgbClr val="5B6B68"/>
+                </a:solidFill>
+                <a:latin typeface="Calibri" pitchFamily="34" charset="0"/>
+                <a:ea typeface="Calibri" pitchFamily="34" charset="-122"/>
+                <a:cs typeface="Calibri" pitchFamily="34" charset="-120"/>
+              </a:rPr>
+              <a:t> /5</a:t>
+            </a:r>
+            <a:endParaRPr lang="en-US" sz="3000" dirty="0"/>
+          </a:p>
+        </p:txBody>
+      </p:sp>
+      <p:sp>
+        <p:nvSpPr>
+          <p:cNvPr id="18" name="Text 16"/>
+          <p:cNvSpPr/>
+          <p:nvPr/>
+        </p:nvSpPr>
+        <p:spPr>
+          <a:xfrm>
+            <a:off x="5806440" y="3172968"/>
+            <a:ext cx="1920240" cy="365760"/>
+          </a:xfrm>
+          <a:prstGeom prst="rect">
+            <a:avLst/>
+          </a:prstGeom>
+          <a:noFill/>
+          <a:ln/>
+        </p:spPr>
+        <p:txBody>
+          <a:bodyPr wrap="square" lIns="0" tIns="0" rIns="0" bIns="0" rtlCol="0" anchor="ctr"/>
+          <a:lstStyle/>
+          <a:p>
+            <a:pPr indent="0" marL="0">
+              <a:buNone/>
+            </a:pPr>
+            <a:r>
+              <a:rPr lang="en-US" sz="1250" dirty="0">
+                <a:solidFill>
+                  <a:srgbClr val="1E293B"/>
+                </a:solidFill>
+                <a:latin typeface="Calibri" pitchFamily="34" charset="0"/>
+                <a:ea typeface="Calibri" pitchFamily="34" charset="-122"/>
+                <a:cs typeface="Calibri" pitchFamily="34" charset="-120"/>
+              </a:rPr>
+              <a:t>Coherence</a:t>
+            </a:r>
+            <a:endParaRPr lang="en-US" sz="1250" dirty="0"/>
+          </a:p>
+        </p:txBody>
+      </p:sp>
+      <p:sp>
+        <p:nvSpPr>
+          <p:cNvPr id="19" name="Text 17"/>
+          <p:cNvSpPr/>
+          <p:nvPr/>
+        </p:nvSpPr>
+        <p:spPr>
+          <a:xfrm>
+            <a:off x="4562856" y="3931920"/>
+            <a:ext cx="1371600" cy="548640"/>
+          </a:xfrm>
+          <a:prstGeom prst="rect">
+            <a:avLst/>
+          </a:prstGeom>
+          <a:noFill/>
+          <a:ln/>
+        </p:spPr>
+        <p:txBody>
+          <a:bodyPr wrap="square" lIns="0" tIns="0" rIns="0" bIns="0" rtlCol="0" anchor="ctr"/>
+          <a:lstStyle/>
+          <a:p>
+            <a:pPr indent="0" marL="0">
+              <a:buNone/>
+            </a:pPr>
+            <a:r>
+              <a:rPr lang="en-US" sz="3000" b="1" dirty="0">
+                <a:solidFill>
+                  <a:srgbClr val="0F6E56"/>
+                </a:solidFill>
+                <a:latin typeface="Cambria" pitchFamily="34" charset="0"/>
+                <a:ea typeface="Cambria" pitchFamily="34" charset="-122"/>
+                <a:cs typeface="Cambria" pitchFamily="34" charset="-120"/>
+              </a:rPr>
+              <a:t>4.9</a:t>
+            </a:r>
+            <a:pPr indent="0" marL="0">
+              <a:buNone/>
+            </a:pPr>
+            <a:r>
+              <a:rPr lang="en-US" sz="1400" dirty="0">
+                <a:solidFill>
+                  <a:srgbClr val="5B6B68"/>
+                </a:solidFill>
+                <a:latin typeface="Calibri" pitchFamily="34" charset="0"/>
+                <a:ea typeface="Calibri" pitchFamily="34" charset="-122"/>
+                <a:cs typeface="Calibri" pitchFamily="34" charset="-120"/>
+              </a:rPr>
+              <a:t> /5</a:t>
+            </a:r>
+            <a:endParaRPr lang="en-US" sz="3000" dirty="0"/>
+          </a:p>
+        </p:txBody>
+      </p:sp>
+      <p:sp>
+        <p:nvSpPr>
+          <p:cNvPr id="20" name="Text 18"/>
+          <p:cNvSpPr/>
+          <p:nvPr/>
+        </p:nvSpPr>
+        <p:spPr>
+          <a:xfrm>
+            <a:off x="5806440" y="4041648"/>
+            <a:ext cx="1920240" cy="365760"/>
+          </a:xfrm>
+          <a:prstGeom prst="rect">
+            <a:avLst/>
+          </a:prstGeom>
+          <a:noFill/>
+          <a:ln/>
+        </p:spPr>
+        <p:txBody>
+          <a:bodyPr wrap="square" lIns="0" tIns="0" rIns="0" bIns="0" rtlCol="0" anchor="ctr"/>
+          <a:lstStyle/>
+          <a:p>
+            <a:pPr indent="0" marL="0">
+              <a:buNone/>
+            </a:pPr>
+            <a:r>
+              <a:rPr lang="en-US" sz="1250" dirty="0">
+                <a:solidFill>
+                  <a:srgbClr val="1E293B"/>
+                </a:solidFill>
+                <a:latin typeface="Calibri" pitchFamily="34" charset="0"/>
+                <a:ea typeface="Calibri" pitchFamily="34" charset="-122"/>
+                <a:cs typeface="Calibri" pitchFamily="34" charset="-120"/>
+              </a:rPr>
+              <a:t>Intent resolution</a:t>
+            </a:r>
+            <a:endParaRPr lang="en-US" sz="1250" dirty="0"/>
+          </a:p>
+        </p:txBody>
+      </p:sp>
+      <p:sp>
+        <p:nvSpPr>
+          <p:cNvPr id="21" name="Text 19"/>
+          <p:cNvSpPr/>
+          <p:nvPr/>
+        </p:nvSpPr>
+        <p:spPr>
+          <a:xfrm>
+            <a:off x="4562856" y="4800600"/>
+            <a:ext cx="1371600" cy="548640"/>
+          </a:xfrm>
+          <a:prstGeom prst="rect">
+            <a:avLst/>
+          </a:prstGeom>
+          <a:noFill/>
+          <a:ln/>
+        </p:spPr>
+        <p:txBody>
+          <a:bodyPr wrap="square" lIns="0" tIns="0" rIns="0" bIns="0" rtlCol="0" anchor="ctr"/>
+          <a:lstStyle/>
+          <a:p>
+            <a:pPr indent="0" marL="0">
+              <a:buNone/>
+            </a:pPr>
+            <a:r>
+              <a:rPr lang="en-US" sz="3000" b="1" dirty="0">
+                <a:solidFill>
+                  <a:srgbClr val="0F6E56"/>
+                </a:solidFill>
+                <a:latin typeface="Cambria" pitchFamily="34" charset="0"/>
+                <a:ea typeface="Cambria" pitchFamily="34" charset="-122"/>
+                <a:cs typeface="Cambria" pitchFamily="34" charset="-120"/>
+              </a:rPr>
+              <a:t>4.0</a:t>
+            </a:r>
+            <a:pPr indent="0" marL="0">
+              <a:buNone/>
+            </a:pPr>
+            <a:r>
+              <a:rPr lang="en-US" sz="1400" dirty="0">
+                <a:solidFill>
+                  <a:srgbClr val="5B6B68"/>
+                </a:solidFill>
+                <a:latin typeface="Calibri" pitchFamily="34" charset="0"/>
+                <a:ea typeface="Calibri" pitchFamily="34" charset="-122"/>
+                <a:cs typeface="Calibri" pitchFamily="34" charset="-120"/>
+              </a:rPr>
+              <a:t> /5</a:t>
+            </a:r>
+            <a:endParaRPr lang="en-US" sz="3000" dirty="0"/>
+          </a:p>
+        </p:txBody>
+      </p:sp>
+      <p:sp>
+        <p:nvSpPr>
+          <p:cNvPr id="22" name="Text 20"/>
+          <p:cNvSpPr/>
+          <p:nvPr/>
+        </p:nvSpPr>
+        <p:spPr>
+          <a:xfrm>
+            <a:off x="5806440" y="4910328"/>
+            <a:ext cx="1920240" cy="365760"/>
+          </a:xfrm>
+          <a:prstGeom prst="rect">
+            <a:avLst/>
+          </a:prstGeom>
+          <a:noFill/>
+          <a:ln/>
+        </p:spPr>
+        <p:txBody>
+          <a:bodyPr wrap="square" lIns="0" tIns="0" rIns="0" bIns="0" rtlCol="0" anchor="ctr"/>
+          <a:lstStyle/>
+          <a:p>
+            <a:pPr indent="0" marL="0">
+              <a:buNone/>
+            </a:pPr>
+            <a:r>
+              <a:rPr lang="en-US" sz="1250" dirty="0">
+                <a:solidFill>
+                  <a:srgbClr val="1E293B"/>
+                </a:solidFill>
+                <a:latin typeface="Calibri" pitchFamily="34" charset="0"/>
+                <a:ea typeface="Calibri" pitchFamily="34" charset="-122"/>
+                <a:cs typeface="Calibri" pitchFamily="34" charset="-120"/>
+              </a:rPr>
+              <a:t>Fluency</a:t>
+            </a:r>
+            <a:endParaRPr lang="en-US" sz="1250" dirty="0"/>
+          </a:p>
+        </p:txBody>
+      </p:sp>
+      <p:sp>
+        <p:nvSpPr>
+          <p:cNvPr id="23" name="Text 21"/>
+          <p:cNvSpPr/>
+          <p:nvPr/>
+        </p:nvSpPr>
+        <p:spPr>
+          <a:xfrm>
+            <a:off x="4562856" y="5669280"/>
+            <a:ext cx="3108960" cy="274320"/>
+          </a:xfrm>
+          <a:prstGeom prst="rect">
+            <a:avLst/>
+          </a:prstGeom>
+          <a:noFill/>
+          <a:ln/>
+        </p:spPr>
+        <p:txBody>
+          <a:bodyPr wrap="square" lIns="0" tIns="0" rIns="0" bIns="0" rtlCol="0" anchor="ctr"/>
+          <a:lstStyle/>
+          <a:p>
+            <a:pPr indent="0" marL="0">
+              <a:buNone/>
+            </a:pPr>
+            <a:r>
+              <a:rPr lang="en-US" sz="1050" i="1" dirty="0">
+                <a:solidFill>
+                  <a:srgbClr val="5B6B68"/>
+                </a:solidFill>
+                <a:latin typeface="Calibri" pitchFamily="34" charset="0"/>
+                <a:ea typeface="Calibri" pitchFamily="34" charset="-122"/>
+                <a:cs typeface="Calibri" pitchFamily="34" charset="-120"/>
+              </a:rPr>
+              <a:t>judge model gpt-5-mini · 15 cases</a:t>
+            </a:r>
+            <a:endParaRPr lang="en-US" sz="1050" dirty="0"/>
+          </a:p>
+        </p:txBody>
+      </p:sp>
+      <p:sp>
+        <p:nvSpPr>
+          <p:cNvPr id="24" name="Shape 22"/>
+          <p:cNvSpPr/>
+          <p:nvPr/>
+        </p:nvSpPr>
+        <p:spPr>
+          <a:xfrm>
+            <a:off x="7982712" y="2057400"/>
+            <a:ext cx="3538728" cy="3977640"/>
+          </a:xfrm>
+          <a:prstGeom prst="roundRect">
+            <a:avLst>
+              <a:gd name="adj" fmla="val 2584"/>
+            </a:avLst>
+          </a:prstGeom>
+          <a:solidFill>
+            <a:srgbClr val="E7F4EF"/>
+          </a:solidFill>
+          <a:ln/>
+          <a:effectLst>
+            <a:outerShdw sx="100000" sy="100000" kx="0" ky="0" algn="bl" rotWithShape="0" blurRad="114300" dist="38100" dir="5400000">
+              <a:srgbClr val="0B3B36">
+                <a:alpha val="12000"/>
+              </a:srgbClr>
+            </a:outerShdw>
+          </a:effectLst>
+        </p:spPr>
+      </p:sp>
+      <p:sp>
+        <p:nvSpPr>
+          <p:cNvPr id="25" name="Text 23"/>
+          <p:cNvSpPr/>
+          <p:nvPr/>
+        </p:nvSpPr>
+        <p:spPr>
+          <a:xfrm>
+            <a:off x="8211312" y="2286000"/>
+            <a:ext cx="3108960" cy="320040"/>
+          </a:xfrm>
+          <a:prstGeom prst="rect">
+            <a:avLst/>
+          </a:prstGeom>
+          <a:noFill/>
+          <a:ln/>
+        </p:spPr>
+        <p:txBody>
+          <a:bodyPr wrap="square" lIns="0" tIns="0" rIns="0" bIns="0" rtlCol="0" anchor="ctr"/>
+          <a:lstStyle/>
+          <a:p>
+            <a:pPr indent="0" marL="0">
+              <a:buNone/>
+            </a:pPr>
+            <a:r>
+              <a:rPr lang="en-US" sz="1200" b="1" spc="200" kern="0" dirty="0">
+                <a:solidFill>
+                  <a:srgbClr val="12A47E"/>
+                </a:solidFill>
+                <a:latin typeface="Calibri" pitchFamily="34" charset="0"/>
+                <a:ea typeface="Calibri" pitchFamily="34" charset="-122"/>
+                <a:cs typeface="Calibri" pitchFamily="34" charset="-120"/>
+              </a:rPr>
+              <a:t>SAFETY</a:t>
+            </a:r>
+            <a:endParaRPr lang="en-US" sz="1200" dirty="0"/>
+          </a:p>
+        </p:txBody>
+      </p:sp>
+      <p:sp>
+        <p:nvSpPr>
+          <p:cNvPr id="26" name="Text 24"/>
+          <p:cNvSpPr/>
+          <p:nvPr/>
+        </p:nvSpPr>
+        <p:spPr>
+          <a:xfrm>
+            <a:off x="8211312" y="2578608"/>
+            <a:ext cx="3108960" cy="320040"/>
+          </a:xfrm>
+          <a:prstGeom prst="rect">
+            <a:avLst/>
+          </a:prstGeom>
+          <a:noFill/>
+          <a:ln/>
+        </p:spPr>
+        <p:txBody>
+          <a:bodyPr wrap="square" lIns="0" tIns="0" rIns="0" bIns="0" rtlCol="0" anchor="ctr"/>
+          <a:lstStyle/>
+          <a:p>
+            <a:pPr indent="0" marL="0">
+              <a:buNone/>
+            </a:pPr>
+            <a:r>
+              <a:rPr lang="en-US" sz="1200" i="1" dirty="0">
+                <a:solidFill>
+                  <a:srgbClr val="5B6B68"/>
+                </a:solidFill>
+                <a:latin typeface="Calibri" pitchFamily="34" charset="0"/>
+                <a:ea typeface="Calibri" pitchFamily="34" charset="-122"/>
+                <a:cs typeface="Calibri" pitchFamily="34" charset="-120"/>
+              </a:rPr>
+              <a:t>Foundry safety evaluators</a:t>
+            </a:r>
+            <a:endParaRPr lang="en-US" sz="1200" dirty="0"/>
+          </a:p>
+        </p:txBody>
+      </p:sp>
+      <p:sp>
+        <p:nvSpPr>
+          <p:cNvPr id="27" name="Shape 25"/>
+          <p:cNvSpPr/>
+          <p:nvPr/>
+        </p:nvSpPr>
+        <p:spPr>
+          <a:xfrm>
+            <a:off x="9464040" y="3154680"/>
+            <a:ext cx="868680" cy="868680"/>
+          </a:xfrm>
+          <a:prstGeom prst="ellipse">
+            <a:avLst/>
+          </a:prstGeom>
+          <a:solidFill>
+            <a:srgbClr val="0F6E56"/>
+          </a:solidFill>
+          <a:ln/>
+        </p:spPr>
+      </p:sp>
+      <p:sp>
+        <p:nvSpPr>
+          <p:cNvPr id="28" name="Text 26"/>
+          <p:cNvSpPr/>
+          <p:nvPr/>
+        </p:nvSpPr>
+        <p:spPr>
+          <a:xfrm>
+            <a:off x="9464040" y="3154680"/>
+            <a:ext cx="868680" cy="868680"/>
+          </a:xfrm>
+          <a:prstGeom prst="rect">
+            <a:avLst/>
+          </a:prstGeom>
+          <a:noFill/>
+          <a:ln/>
+        </p:spPr>
+        <p:txBody>
+          <a:bodyPr wrap="square" lIns="0" tIns="0" rIns="0" bIns="0" rtlCol="0" anchor="ctr"/>
+          <a:lstStyle/>
+          <a:p>
+            <a:pPr algn="ctr" indent="0" marL="0">
+              <a:buNone/>
+            </a:pPr>
+            <a:r>
+              <a:rPr lang="en-US" sz="3400" b="1" dirty="0">
+                <a:solidFill>
+                  <a:srgbClr val="FFFFFF"/>
+                </a:solidFill>
+                <a:latin typeface="Calibri" pitchFamily="34" charset="0"/>
+                <a:ea typeface="Calibri" pitchFamily="34" charset="-122"/>
+                <a:cs typeface="Calibri" pitchFamily="34" charset="-120"/>
+              </a:rPr>
+              <a:t>✔</a:t>
+            </a:r>
+            <a:endParaRPr lang="en-US" sz="3400" dirty="0"/>
+          </a:p>
+        </p:txBody>
+      </p:sp>
+      <p:sp>
+        <p:nvSpPr>
+          <p:cNvPr id="29" name="Text 27"/>
+          <p:cNvSpPr/>
+          <p:nvPr/>
+        </p:nvSpPr>
+        <p:spPr>
+          <a:xfrm>
+            <a:off x="8211312" y="4160520"/>
+            <a:ext cx="3108960" cy="365760"/>
+          </a:xfrm>
+          <a:prstGeom prst="rect">
+            <a:avLst/>
+          </a:prstGeom>
+          <a:noFill/>
+          <a:ln/>
+        </p:spPr>
+        <p:txBody>
+          <a:bodyPr wrap="square" lIns="0" tIns="0" rIns="0" bIns="0" rtlCol="0" anchor="ctr"/>
+          <a:lstStyle/>
+          <a:p>
+            <a:pPr algn="ctr" indent="0" marL="0">
+              <a:buNone/>
+            </a:pPr>
+            <a:r>
+              <a:rPr lang="en-US" sz="2000" b="1" dirty="0">
+                <a:solidFill>
+                  <a:srgbClr val="0F6E56"/>
+                </a:solidFill>
+                <a:latin typeface="Cambria" pitchFamily="34" charset="0"/>
+                <a:ea typeface="Cambria" pitchFamily="34" charset="-122"/>
+                <a:cs typeface="Cambria" pitchFamily="34" charset="-120"/>
+              </a:rPr>
+              <a:t>Clean sweep</a:t>
+            </a:r>
+            <a:endParaRPr lang="en-US" sz="2000" dirty="0"/>
+          </a:p>
+        </p:txBody>
+      </p:sp>
+      <p:sp>
+        <p:nvSpPr>
+          <p:cNvPr id="30" name="Text 28"/>
+          <p:cNvSpPr/>
+          <p:nvPr/>
+        </p:nvSpPr>
+        <p:spPr>
+          <a:xfrm>
+            <a:off x="8211312" y="4617720"/>
+            <a:ext cx="3108960" cy="1005840"/>
+          </a:xfrm>
+          <a:prstGeom prst="rect">
+            <a:avLst/>
+          </a:prstGeom>
+          <a:noFill/>
+          <a:ln/>
+        </p:spPr>
+        <p:txBody>
+          <a:bodyPr wrap="square" lIns="0" tIns="0" rIns="0" bIns="0" rtlCol="0" anchor="ctr"/>
+          <a:lstStyle/>
+          <a:p>
+            <a:pPr algn="ctr" indent="0" marL="0">
+              <a:buNone/>
+            </a:pPr>
+            <a:r>
+              <a:rPr lang="en-US" sz="1200" dirty="0">
+                <a:solidFill>
+                  <a:srgbClr val="1E293B"/>
+                </a:solidFill>
+                <a:latin typeface="Calibri" pitchFamily="34" charset="0"/>
+                <a:ea typeface="Calibri" pitchFamily="34" charset="-122"/>
+                <a:cs typeface="Calibri" pitchFamily="34" charset="-120"/>
+              </a:rPr>
+              <a:t>No violence, self-harm, sexual or hateful content. Protected-material, code-vulnerability and indirect-attack checks all pass.</a:t>
+            </a:r>
+            <a:endParaRPr lang="en-US" sz="1200" dirty="0"/>
+          </a:p>
+        </p:txBody>
+      </p:sp>
+      <p:sp>
+        <p:nvSpPr>
+          <p:cNvPr id="31" name="Text 29"/>
+          <p:cNvSpPr/>
+          <p:nvPr/>
+        </p:nvSpPr>
+        <p:spPr>
+          <a:xfrm>
+            <a:off x="640080" y="6172200"/>
+            <a:ext cx="10881360" cy="365760"/>
+          </a:xfrm>
+          <a:prstGeom prst="rect">
+            <a:avLst/>
+          </a:prstGeom>
+          <a:noFill/>
+          <a:ln/>
+        </p:spPr>
+        <p:txBody>
+          <a:bodyPr wrap="square" lIns="0" tIns="0" rIns="0" bIns="0" rtlCol="0" anchor="ctr"/>
+          <a:lstStyle/>
+          <a:p>
+            <a:pPr algn="ctr" indent="0" marL="0">
+              <a:buNone/>
+            </a:pPr>
+            <a:r>
+              <a:rPr lang="en-US" sz="1150" i="1" dirty="0">
+                <a:solidFill>
+                  <a:srgbClr val="5B6B68"/>
+                </a:solidFill>
+                <a:latin typeface="Calibri" pitchFamily="34" charset="0"/>
+                <a:ea typeface="Calibri" pitchFamily="34" charset="-122"/>
+                <a:cs typeface="Calibri" pitchFamily="34" charset="-120"/>
+              </a:rPr>
+              <a:t>Correctness scored against ground truth offline · quality and safety from the Foundry evaluation run.</a:t>
             </a:r>
             <a:endParaRPr lang="en-US" sz="1150" dirty="0"/>
           </a:p>
@@ -2880,7 +3636,7 @@
                 <a:ea typeface="Calibri" pitchFamily="34" charset="-122"/>
                 <a:cs typeface="Calibri" pitchFamily="34" charset="-120"/>
               </a:rPr>
-              <a:t>IMPACT</a:t>
+              <a:t>HUMAN-IN-THE-LOOP</a:t>
             </a:r>
             <a:endParaRPr lang="en-US" sz="1200" dirty="0"/>
           </a:p>
@@ -2919,7 +3675,7 @@
                 <a:ea typeface="Cambria" pitchFamily="34" charset="-122"/>
                 <a:cs typeface="Cambria" pitchFamily="34" charset="-120"/>
               </a:rPr>
-              <a:t>What this gives a team</a:t>
+              <a:t>The gate knows when to ask a human</a:t>
             </a:r>
             <a:endParaRPr lang="en-US" sz="3200" dirty="0"/>
           </a:p>
@@ -2933,16 +3689,16 @@
         </p:nvSpPr>
         <p:spPr>
           <a:xfrm>
-            <a:off x="640080" y="2148840"/>
-            <a:ext cx="10881360" cy="1097280"/>
+            <a:off x="640080" y="2468880"/>
+            <a:ext cx="3474720" cy="1371600"/>
           </a:xfrm>
           <a:prstGeom prst="roundRect">
             <a:avLst>
-              <a:gd name="adj" fmla="val 8333"/>
+              <a:gd name="adj" fmla="val 6667"/>
             </a:avLst>
           </a:prstGeom>
           <a:solidFill>
-            <a:srgbClr val="F0F7F5"/>
+            <a:srgbClr val="E7F4EF"/>
           </a:solidFill>
           <a:ln/>
           <a:effectLst>
@@ -2956,34 +3712,14 @@
       </p:sp>
       <p:sp>
         <p:nvSpPr>
-          <p:cNvPr id="5" name="Shape 3"/>
-          <p:cNvSpPr/>
-          <p:nvPr/>
-        </p:nvSpPr>
-        <p:spPr>
-          <a:xfrm>
-            <a:off x="960120" y="2441448"/>
-            <a:ext cx="512064" cy="512064"/>
-          </a:xfrm>
-          <a:prstGeom prst="ellipse">
-            <a:avLst/>
-          </a:prstGeom>
-          <a:solidFill>
-            <a:srgbClr val="12A47E"/>
-          </a:solidFill>
-          <a:ln/>
-        </p:spPr>
-      </p:sp>
-      <p:sp>
-        <p:nvSpPr>
-          <p:cNvPr id="6" name="Text 4"/>
-          <p:cNvSpPr/>
-          <p:nvPr/>
-        </p:nvSpPr>
-        <p:spPr>
-          <a:xfrm>
-            <a:off x="960120" y="2441448"/>
-            <a:ext cx="512064" cy="512064"/>
+          <p:cNvPr id="5" name="Text 3"/>
+          <p:cNvSpPr/>
+          <p:nvPr/>
+        </p:nvSpPr>
+        <p:spPr>
+          <a:xfrm>
+            <a:off x="640080" y="2724912"/>
+            <a:ext cx="3474720" cy="457200"/>
           </a:xfrm>
           <a:prstGeom prst="rect">
             <a:avLst/>
@@ -2999,116 +3735,77 @@
               <a:buNone/>
             </a:pPr>
             <a:r>
-              <a:rPr lang="en-US" sz="1800" b="1" dirty="0">
-                <a:solidFill>
-                  <a:srgbClr val="FFFFFF"/>
+              <a:rPr lang="en-US" sz="2100" b="1" dirty="0">
+                <a:solidFill>
+                  <a:srgbClr val="0F6E56"/>
                 </a:solidFill>
                 <a:latin typeface="Cambria" pitchFamily="34" charset="0"/>
                 <a:ea typeface="Cambria" pitchFamily="34" charset="-122"/>
                 <a:cs typeface="Cambria" pitchFamily="34" charset="-120"/>
               </a:rPr>
-              <a:t>1</a:t>
-            </a:r>
-            <a:endParaRPr lang="en-US" sz="1800" dirty="0"/>
-          </a:p>
-        </p:txBody>
-      </p:sp>
-      <p:sp>
-        <p:nvSpPr>
-          <p:cNvPr id="7" name="Text 5"/>
-          <p:cNvSpPr/>
-          <p:nvPr/>
-        </p:nvSpPr>
-        <p:spPr>
-          <a:xfrm>
-            <a:off x="1737360" y="2350008"/>
-            <a:ext cx="9509760" cy="411480"/>
-          </a:xfrm>
-          <a:prstGeom prst="rect">
-            <a:avLst/>
-          </a:prstGeom>
-          <a:noFill/>
-          <a:ln/>
-        </p:spPr>
-        <p:txBody>
-          <a:bodyPr wrap="square" lIns="0" tIns="0" rIns="0" bIns="0" rtlCol="0" anchor="ctr"/>
-          <a:lstStyle/>
-          <a:p>
-            <a:pPr indent="0" marL="0">
-              <a:buNone/>
-            </a:pPr>
-            <a:r>
-              <a:rPr lang="en-US" sz="1900" b="1" dirty="0">
-                <a:solidFill>
-                  <a:srgbClr val="0F6E56"/>
-                </a:solidFill>
-                <a:latin typeface="Cambria" pitchFamily="34" charset="0"/>
-                <a:ea typeface="Cambria" pitchFamily="34" charset="-122"/>
-                <a:cs typeface="Cambria" pitchFamily="34" charset="-120"/>
-              </a:rPr>
-              <a:t>Faster, consistent planning</a:t>
-            </a:r>
-            <a:endParaRPr lang="en-US" sz="1900" dirty="0"/>
-          </a:p>
-        </p:txBody>
-      </p:sp>
-      <p:sp>
-        <p:nvSpPr>
-          <p:cNvPr id="8" name="Text 6"/>
-          <p:cNvSpPr/>
-          <p:nvPr/>
-        </p:nvSpPr>
-        <p:spPr>
-          <a:xfrm>
-            <a:off x="1737360" y="2752344"/>
-            <a:ext cx="9509760" cy="365760"/>
-          </a:xfrm>
-          <a:prstGeom prst="rect">
-            <a:avLst/>
-          </a:prstGeom>
-          <a:noFill/>
-          <a:ln/>
-        </p:spPr>
-        <p:txBody>
-          <a:bodyPr wrap="square" lIns="0" tIns="0" rIns="0" bIns="0" rtlCol="0" anchor="ctr"/>
-          <a:lstStyle/>
-          <a:p>
-            <a:pPr indent="0" marL="0">
-              <a:buNone/>
-            </a:pPr>
-            <a:r>
-              <a:rPr lang="en-US" sz="1450" dirty="0">
-                <a:solidFill>
-                  <a:srgbClr val="5B6B68"/>
+              <a:t>PASS</a:t>
+            </a:r>
+            <a:endParaRPr lang="en-US" sz="2100" dirty="0"/>
+          </a:p>
+        </p:txBody>
+      </p:sp>
+      <p:sp>
+        <p:nvSpPr>
+          <p:cNvPr id="6" name="Text 4"/>
+          <p:cNvSpPr/>
+          <p:nvPr/>
+        </p:nvSpPr>
+        <p:spPr>
+          <a:xfrm>
+            <a:off x="822960" y="3218688"/>
+            <a:ext cx="3108960" cy="502920"/>
+          </a:xfrm>
+          <a:prstGeom prst="rect">
+            <a:avLst/>
+          </a:prstGeom>
+          <a:noFill/>
+          <a:ln/>
+        </p:spPr>
+        <p:txBody>
+          <a:bodyPr wrap="square" lIns="0" tIns="0" rIns="0" bIns="0" rtlCol="0" anchor="ctr"/>
+          <a:lstStyle/>
+          <a:p>
+            <a:pPr algn="ctr" indent="0" marL="0">
+              <a:buNone/>
+            </a:pPr>
+            <a:r>
+              <a:rPr lang="en-US" sz="1250" dirty="0">
+                <a:solidFill>
+                  <a:srgbClr val="1E293B"/>
                 </a:solidFill>
                 <a:latin typeface="Calibri" pitchFamily="34" charset="0"/>
                 <a:ea typeface="Calibri" pitchFamily="34" charset="-122"/>
                 <a:cs typeface="Calibri" pitchFamily="34" charset="-120"/>
               </a:rPr>
-              <a:t>Weak stories are filtered before they reach the board.</a:t>
-            </a:r>
-            <a:endParaRPr lang="en-US" sz="1450" dirty="0"/>
-          </a:p>
-        </p:txBody>
-      </p:sp>
-      <p:sp>
-        <p:nvSpPr>
-          <p:cNvPr id="9" name="Shape 7"/>
-          <p:cNvSpPr/>
-          <p:nvPr/>
-        </p:nvSpPr>
-        <p:spPr>
-          <a:xfrm>
-            <a:off x="640080" y="3429000"/>
-            <a:ext cx="10881360" cy="1097280"/>
+              <a:t>clear score → auto-plan</a:t>
+            </a:r>
+            <a:endParaRPr lang="en-US" sz="1250" dirty="0"/>
+          </a:p>
+        </p:txBody>
+      </p:sp>
+      <p:sp>
+        <p:nvSpPr>
+          <p:cNvPr id="7" name="Shape 5"/>
+          <p:cNvSpPr/>
+          <p:nvPr/>
+        </p:nvSpPr>
+        <p:spPr>
+          <a:xfrm>
+            <a:off x="4343400" y="2468880"/>
+            <a:ext cx="3520440" cy="1371600"/>
           </a:xfrm>
           <a:prstGeom prst="roundRect">
             <a:avLst>
-              <a:gd name="adj" fmla="val 8333"/>
+              <a:gd name="adj" fmla="val 6667"/>
             </a:avLst>
           </a:prstGeom>
           <a:solidFill>
-            <a:srgbClr val="F0F7F5"/>
+            <a:srgbClr val="FBF1DD"/>
           </a:solidFill>
           <a:ln/>
           <a:effectLst>
@@ -3122,34 +3819,14 @@
       </p:sp>
       <p:sp>
         <p:nvSpPr>
-          <p:cNvPr id="10" name="Shape 8"/>
-          <p:cNvSpPr/>
-          <p:nvPr/>
-        </p:nvSpPr>
-        <p:spPr>
-          <a:xfrm>
-            <a:off x="960120" y="3721608"/>
-            <a:ext cx="512064" cy="512064"/>
-          </a:xfrm>
-          <a:prstGeom prst="ellipse">
-            <a:avLst/>
-          </a:prstGeom>
-          <a:solidFill>
-            <a:srgbClr val="12A47E"/>
-          </a:solidFill>
-          <a:ln/>
-        </p:spPr>
-      </p:sp>
-      <p:sp>
-        <p:nvSpPr>
-          <p:cNvPr id="11" name="Text 9"/>
-          <p:cNvSpPr/>
-          <p:nvPr/>
-        </p:nvSpPr>
-        <p:spPr>
-          <a:xfrm>
-            <a:off x="960120" y="3721608"/>
-            <a:ext cx="512064" cy="512064"/>
+          <p:cNvPr id="8" name="Text 6"/>
+          <p:cNvSpPr/>
+          <p:nvPr/>
+        </p:nvSpPr>
+        <p:spPr>
+          <a:xfrm>
+            <a:off x="4343400" y="2724912"/>
+            <a:ext cx="3520440" cy="457200"/>
           </a:xfrm>
           <a:prstGeom prst="rect">
             <a:avLst/>
@@ -3165,116 +3842,77 @@
               <a:buNone/>
             </a:pPr>
             <a:r>
-              <a:rPr lang="en-US" sz="1800" b="1" dirty="0">
-                <a:solidFill>
-                  <a:srgbClr val="FFFFFF"/>
+              <a:rPr lang="en-US" sz="2100" b="1" dirty="0">
+                <a:solidFill>
+                  <a:srgbClr val="B07A0A"/>
                 </a:solidFill>
                 <a:latin typeface="Cambria" pitchFamily="34" charset="0"/>
                 <a:ea typeface="Cambria" pitchFamily="34" charset="-122"/>
                 <a:cs typeface="Cambria" pitchFamily="34" charset="-120"/>
               </a:rPr>
-              <a:t>2</a:t>
-            </a:r>
-            <a:endParaRPr lang="en-US" sz="1800" dirty="0"/>
-          </a:p>
-        </p:txBody>
-      </p:sp>
-      <p:sp>
-        <p:nvSpPr>
-          <p:cNvPr id="12" name="Text 10"/>
-          <p:cNvSpPr/>
-          <p:nvPr/>
-        </p:nvSpPr>
-        <p:spPr>
-          <a:xfrm>
-            <a:off x="1737360" y="3630168"/>
-            <a:ext cx="9509760" cy="411480"/>
-          </a:xfrm>
-          <a:prstGeom prst="rect">
-            <a:avLst/>
-          </a:prstGeom>
-          <a:noFill/>
-          <a:ln/>
-        </p:spPr>
-        <p:txBody>
-          <a:bodyPr wrap="square" lIns="0" tIns="0" rIns="0" bIns="0" rtlCol="0" anchor="ctr"/>
-          <a:lstStyle/>
-          <a:p>
-            <a:pPr indent="0" marL="0">
-              <a:buNone/>
-            </a:pPr>
-            <a:r>
-              <a:rPr lang="en-US" sz="1900" b="1" dirty="0">
-                <a:solidFill>
-                  <a:srgbClr val="0F6E56"/>
-                </a:solidFill>
-                <a:latin typeface="Cambria" pitchFamily="34" charset="0"/>
-                <a:ea typeface="Cambria" pitchFamily="34" charset="-122"/>
-                <a:cs typeface="Cambria" pitchFamily="34" charset="-120"/>
-              </a:rPr>
-              <a:t>A measurable quality gate</a:t>
-            </a:r>
-            <a:endParaRPr lang="en-US" sz="1900" dirty="0"/>
-          </a:p>
-        </p:txBody>
-      </p:sp>
-      <p:sp>
-        <p:nvSpPr>
-          <p:cNvPr id="13" name="Text 11"/>
-          <p:cNvSpPr/>
-          <p:nvPr/>
-        </p:nvSpPr>
-        <p:spPr>
-          <a:xfrm>
-            <a:off x="1737360" y="4032504"/>
-            <a:ext cx="9509760" cy="365760"/>
-          </a:xfrm>
-          <a:prstGeom prst="rect">
-            <a:avLst/>
-          </a:prstGeom>
-          <a:noFill/>
-          <a:ln/>
-        </p:spPr>
-        <p:txBody>
-          <a:bodyPr wrap="square" lIns="0" tIns="0" rIns="0" bIns="0" rtlCol="0" anchor="ctr"/>
-          <a:lstStyle/>
-          <a:p>
-            <a:pPr indent="0" marL="0">
-              <a:buNone/>
-            </a:pPr>
-            <a:r>
-              <a:rPr lang="en-US" sz="1450" dirty="0">
-                <a:solidFill>
-                  <a:srgbClr val="5B6B68"/>
+              <a:t>REVIEW</a:t>
+            </a:r>
+            <a:endParaRPr lang="en-US" sz="2100" dirty="0"/>
+          </a:p>
+        </p:txBody>
+      </p:sp>
+      <p:sp>
+        <p:nvSpPr>
+          <p:cNvPr id="9" name="Text 7"/>
+          <p:cNvSpPr/>
+          <p:nvPr/>
+        </p:nvSpPr>
+        <p:spPr>
+          <a:xfrm>
+            <a:off x="4526280" y="3218688"/>
+            <a:ext cx="3154680" cy="502920"/>
+          </a:xfrm>
+          <a:prstGeom prst="rect">
+            <a:avLst/>
+          </a:prstGeom>
+          <a:noFill/>
+          <a:ln/>
+        </p:spPr>
+        <p:txBody>
+          <a:bodyPr wrap="square" lIns="0" tIns="0" rIns="0" bIns="0" rtlCol="0" anchor="ctr"/>
+          <a:lstStyle/>
+          <a:p>
+            <a:pPr algn="ctr" indent="0" marL="0">
+              <a:buNone/>
+            </a:pPr>
+            <a:r>
+              <a:rPr lang="en-US" sz="1250" dirty="0">
+                <a:solidFill>
+                  <a:srgbClr val="1E293B"/>
                 </a:solidFill>
                 <a:latin typeface="Calibri" pitchFamily="34" charset="0"/>
                 <a:ea typeface="Calibri" pitchFamily="34" charset="-122"/>
                 <a:cs typeface="Calibri" pitchFamily="34" charset="-120"/>
               </a:rPr>
-              <a:t>Pass-rate is a backlog-health KPI, not a subjective call.</a:t>
-            </a:r>
-            <a:endParaRPr lang="en-US" sz="1450" dirty="0"/>
-          </a:p>
-        </p:txBody>
-      </p:sp>
-      <p:sp>
-        <p:nvSpPr>
-          <p:cNvPr id="14" name="Shape 12"/>
-          <p:cNvSpPr/>
-          <p:nvPr/>
-        </p:nvSpPr>
-        <p:spPr>
-          <a:xfrm>
-            <a:off x="640080" y="4709160"/>
-            <a:ext cx="10881360" cy="1097280"/>
+              <a:t>borderline or hard-blocked → a person decides</a:t>
+            </a:r>
+            <a:endParaRPr lang="en-US" sz="1250" dirty="0"/>
+          </a:p>
+        </p:txBody>
+      </p:sp>
+      <p:sp>
+        <p:nvSpPr>
+          <p:cNvPr id="10" name="Shape 8"/>
+          <p:cNvSpPr/>
+          <p:nvPr/>
+        </p:nvSpPr>
+        <p:spPr>
+          <a:xfrm>
+            <a:off x="8046720" y="2468880"/>
+            <a:ext cx="3474720" cy="1371600"/>
           </a:xfrm>
           <a:prstGeom prst="roundRect">
             <a:avLst>
-              <a:gd name="adj" fmla="val 8333"/>
+              <a:gd name="adj" fmla="val 6667"/>
             </a:avLst>
           </a:prstGeom>
           <a:solidFill>
-            <a:srgbClr val="F0F7F5"/>
+            <a:srgbClr val="FBE3DE"/>
           </a:solidFill>
           <a:ln/>
           <a:effectLst>
@@ -3288,34 +3926,14 @@
       </p:sp>
       <p:sp>
         <p:nvSpPr>
-          <p:cNvPr id="15" name="Shape 13"/>
-          <p:cNvSpPr/>
-          <p:nvPr/>
-        </p:nvSpPr>
-        <p:spPr>
-          <a:xfrm>
-            <a:off x="960120" y="5001768"/>
-            <a:ext cx="512064" cy="512064"/>
-          </a:xfrm>
-          <a:prstGeom prst="ellipse">
-            <a:avLst/>
-          </a:prstGeom>
-          <a:solidFill>
-            <a:srgbClr val="0F6E56"/>
-          </a:solidFill>
-          <a:ln/>
-        </p:spPr>
-      </p:sp>
-      <p:sp>
-        <p:nvSpPr>
-          <p:cNvPr id="16" name="Text 14"/>
-          <p:cNvSpPr/>
-          <p:nvPr/>
-        </p:nvSpPr>
-        <p:spPr>
-          <a:xfrm>
-            <a:off x="960120" y="5001768"/>
-            <a:ext cx="512064" cy="512064"/>
+          <p:cNvPr id="11" name="Text 9"/>
+          <p:cNvSpPr/>
+          <p:nvPr/>
+        </p:nvSpPr>
+        <p:spPr>
+          <a:xfrm>
+            <a:off x="8046720" y="2724912"/>
+            <a:ext cx="3474720" cy="457200"/>
           </a:xfrm>
           <a:prstGeom prst="rect">
             <a:avLst/>
@@ -3331,46 +3949,192 @@
               <a:buNone/>
             </a:pPr>
             <a:r>
-              <a:rPr lang="en-US" sz="1800" b="1" dirty="0">
-                <a:solidFill>
-                  <a:srgbClr val="FFFFFF"/>
+              <a:rPr lang="en-US" sz="2100" b="1" dirty="0">
+                <a:solidFill>
+                  <a:srgbClr val="B23A2E"/>
                 </a:solidFill>
                 <a:latin typeface="Cambria" pitchFamily="34" charset="0"/>
                 <a:ea typeface="Cambria" pitchFamily="34" charset="-122"/>
                 <a:cs typeface="Cambria" pitchFamily="34" charset="-120"/>
               </a:rPr>
-              <a:t>3</a:t>
-            </a:r>
-            <a:endParaRPr lang="en-US" sz="1800" dirty="0"/>
-          </a:p>
-        </p:txBody>
-      </p:sp>
-      <p:sp>
-        <p:nvSpPr>
-          <p:cNvPr id="17" name="Text 15"/>
-          <p:cNvSpPr/>
-          <p:nvPr/>
-        </p:nvSpPr>
-        <p:spPr>
-          <a:xfrm>
-            <a:off x="1737360" y="4910328"/>
-            <a:ext cx="9509760" cy="411480"/>
-          </a:xfrm>
-          <a:prstGeom prst="rect">
-            <a:avLst/>
-          </a:prstGeom>
-          <a:noFill/>
-          <a:ln/>
-        </p:spPr>
-        <p:txBody>
-          <a:bodyPr wrap="square" lIns="0" tIns="0" rIns="0" bIns="0" rtlCol="0" anchor="ctr"/>
-          <a:lstStyle/>
-          <a:p>
-            <a:pPr indent="0" marL="0">
-              <a:buNone/>
-            </a:pPr>
-            <a:r>
-              <a:rPr lang="en-US" sz="1900" b="1" dirty="0">
+              <a:t>REJECT</a:t>
+            </a:r>
+            <a:endParaRPr lang="en-US" sz="2100" dirty="0"/>
+          </a:p>
+        </p:txBody>
+      </p:sp>
+      <p:sp>
+        <p:nvSpPr>
+          <p:cNvPr id="12" name="Text 10"/>
+          <p:cNvSpPr/>
+          <p:nvPr/>
+        </p:nvSpPr>
+        <p:spPr>
+          <a:xfrm>
+            <a:off x="8229600" y="3218688"/>
+            <a:ext cx="3108960" cy="502920"/>
+          </a:xfrm>
+          <a:prstGeom prst="rect">
+            <a:avLst/>
+          </a:prstGeom>
+          <a:noFill/>
+          <a:ln/>
+        </p:spPr>
+        <p:txBody>
+          <a:bodyPr wrap="square" lIns="0" tIns="0" rIns="0" bIns="0" rtlCol="0" anchor="ctr"/>
+          <a:lstStyle/>
+          <a:p>
+            <a:pPr algn="ctr" indent="0" marL="0">
+              <a:buNone/>
+            </a:pPr>
+            <a:r>
+              <a:rPr lang="en-US" sz="1250" dirty="0">
+                <a:solidFill>
+                  <a:srgbClr val="1E293B"/>
+                </a:solidFill>
+                <a:latin typeface="Calibri" pitchFamily="34" charset="0"/>
+                <a:ea typeface="Calibri" pitchFamily="34" charset="-122"/>
+                <a:cs typeface="Calibri" pitchFamily="34" charset="-120"/>
+              </a:rPr>
+              <a:t>clear fail → sent back</a:t>
+            </a:r>
+            <a:endParaRPr lang="en-US" sz="1250" dirty="0"/>
+          </a:p>
+        </p:txBody>
+      </p:sp>
+      <p:sp>
+        <p:nvSpPr>
+          <p:cNvPr id="13" name="Text 11"/>
+          <p:cNvSpPr/>
+          <p:nvPr/>
+        </p:nvSpPr>
+        <p:spPr>
+          <a:xfrm>
+            <a:off x="640080" y="4160520"/>
+            <a:ext cx="10881360" cy="365760"/>
+          </a:xfrm>
+          <a:prstGeom prst="rect">
+            <a:avLst/>
+          </a:prstGeom>
+          <a:noFill/>
+          <a:ln/>
+        </p:spPr>
+        <p:txBody>
+          <a:bodyPr wrap="square" lIns="0" tIns="0" rIns="0" bIns="0" rtlCol="0" anchor="ctr"/>
+          <a:lstStyle/>
+          <a:p>
+            <a:pPr algn="ctr" indent="0" marL="0">
+              <a:buNone/>
+            </a:pPr>
+            <a:r>
+              <a:rPr lang="en-US" sz="1400" dirty="0">
+                <a:solidFill>
+                  <a:srgbClr val="5B6B68"/>
+                </a:solidFill>
+                <a:latin typeface="Calibri" pitchFamily="34" charset="0"/>
+                <a:ea typeface="Calibri" pitchFamily="34" charset="-122"/>
+                <a:cs typeface="Calibri" pitchFamily="34" charset="-120"/>
+              </a:rPr>
+              <a:t>A configurable review band and hard blockers (e.g. an unstated dependency) route uncertain stories to review —</a:t>
+            </a:r>
+            <a:endParaRPr lang="en-US" sz="1400" dirty="0"/>
+          </a:p>
+        </p:txBody>
+      </p:sp>
+      <p:sp>
+        <p:nvSpPr>
+          <p:cNvPr id="14" name="Text 12"/>
+          <p:cNvSpPr/>
+          <p:nvPr/>
+        </p:nvSpPr>
+        <p:spPr>
+          <a:xfrm>
+            <a:off x="640080" y="4480560"/>
+            <a:ext cx="10881360" cy="365760"/>
+          </a:xfrm>
+          <a:prstGeom prst="rect">
+            <a:avLst/>
+          </a:prstGeom>
+          <a:noFill/>
+          <a:ln/>
+        </p:spPr>
+        <p:txBody>
+          <a:bodyPr wrap="square" lIns="0" tIns="0" rIns="0" bIns="0" rtlCol="0" anchor="ctr"/>
+          <a:lstStyle/>
+          <a:p>
+            <a:pPr algn="ctr" indent="0" marL="0">
+              <a:buNone/>
+            </a:pPr>
+            <a:r>
+              <a:rPr lang="en-US" sz="1400" dirty="0">
+                <a:solidFill>
+                  <a:srgbClr val="5B6B68"/>
+                </a:solidFill>
+                <a:latin typeface="Calibri" pitchFamily="34" charset="0"/>
+                <a:ea typeface="Calibri" pitchFamily="34" charset="-122"/>
+                <a:cs typeface="Calibri" pitchFamily="34" charset="-120"/>
+              </a:rPr>
+              <a:t>the reviewer's decision is logged as a new ground-truth label, so the gate learns from the cases it found hard.</a:t>
+            </a:r>
+            <a:endParaRPr lang="en-US" sz="1400" dirty="0"/>
+          </a:p>
+        </p:txBody>
+      </p:sp>
+      <p:sp>
+        <p:nvSpPr>
+          <p:cNvPr id="15" name="Shape 13"/>
+          <p:cNvSpPr/>
+          <p:nvPr/>
+        </p:nvSpPr>
+        <p:spPr>
+          <a:xfrm>
+            <a:off x="2377440" y="5166360"/>
+            <a:ext cx="7406640" cy="960120"/>
+          </a:xfrm>
+          <a:prstGeom prst="roundRect">
+            <a:avLst>
+              <a:gd name="adj" fmla="val 9524"/>
+            </a:avLst>
+          </a:prstGeom>
+          <a:solidFill>
+            <a:srgbClr val="E7F4EF"/>
+          </a:solidFill>
+          <a:ln/>
+          <a:effectLst>
+            <a:outerShdw sx="100000" sy="100000" kx="0" ky="0" algn="bl" rotWithShape="0" blurRad="114300" dist="38100" dir="5400000">
+              <a:srgbClr val="0B3B36">
+                <a:alpha val="12000"/>
+              </a:srgbClr>
+            </a:outerShdw>
+          </a:effectLst>
+        </p:spPr>
+      </p:sp>
+      <p:sp>
+        <p:nvSpPr>
+          <p:cNvPr id="16" name="Text 14"/>
+          <p:cNvSpPr/>
+          <p:nvPr/>
+        </p:nvSpPr>
+        <p:spPr>
+          <a:xfrm>
+            <a:off x="2377440" y="5166360"/>
+            <a:ext cx="7406640" cy="960120"/>
+          </a:xfrm>
+          <a:prstGeom prst="rect">
+            <a:avLst/>
+          </a:prstGeom>
+          <a:noFill/>
+          <a:ln/>
+        </p:spPr>
+        <p:txBody>
+          <a:bodyPr wrap="square" lIns="0" tIns="0" rIns="0" bIns="0" rtlCol="0" anchor="ctr"/>
+          <a:lstStyle/>
+          <a:p>
+            <a:pPr algn="ctr" indent="0" marL="0">
+              <a:buNone/>
+            </a:pPr>
+            <a:r>
+              <a:rPr lang="en-US" sz="1500" i="1" dirty="0">
                 <a:solidFill>
                   <a:srgbClr val="0F6E56"/>
                 </a:solidFill>
@@ -3378,48 +4142,9 @@
                 <a:ea typeface="Cambria" pitchFamily="34" charset="-122"/>
                 <a:cs typeface="Cambria" pitchFamily="34" charset="-120"/>
               </a:rPr>
-              <a:t>Itself governed</a:t>
-            </a:r>
-            <a:endParaRPr lang="en-US" sz="1900" dirty="0"/>
-          </a:p>
-        </p:txBody>
-      </p:sp>
-      <p:sp>
-        <p:nvSpPr>
-          <p:cNvPr id="18" name="Text 16"/>
-          <p:cNvSpPr/>
-          <p:nvPr/>
-        </p:nvSpPr>
-        <p:spPr>
-          <a:xfrm>
-            <a:off x="1737360" y="5312664"/>
-            <a:ext cx="9509760" cy="365760"/>
-          </a:xfrm>
-          <a:prstGeom prst="rect">
-            <a:avLst/>
-          </a:prstGeom>
-          <a:noFill/>
-          <a:ln/>
-        </p:spPr>
-        <p:txBody>
-          <a:bodyPr wrap="square" lIns="0" tIns="0" rIns="0" bIns="0" rtlCol="0" anchor="ctr"/>
-          <a:lstStyle/>
-          <a:p>
-            <a:pPr indent="0" marL="0">
-              <a:buNone/>
-            </a:pPr>
-            <a:r>
-              <a:rPr lang="en-US" sz="1450" dirty="0">
-                <a:solidFill>
-                  <a:srgbClr val="5B6B68"/>
-                </a:solidFill>
-                <a:latin typeface="Calibri" pitchFamily="34" charset="0"/>
-                <a:ea typeface="Calibri" pitchFamily="34" charset="-122"/>
-                <a:cs typeface="Calibri" pitchFamily="34" charset="-120"/>
-              </a:rPr>
-              <a:t>Every decision is traced; every agent is evaluated.</a:t>
-            </a:r>
-            <a:endParaRPr lang="en-US" sz="1450" dirty="0"/>
+              <a:t>pass → plan   ·   reject → feedback   ·   review → human → decision feeds back into evaluation</a:t>
+            </a:r>
+            <a:endParaRPr lang="en-US" sz="1500" dirty="0"/>
           </a:p>
         </p:txBody>
       </p:sp>
@@ -3434,6 +4159,1175 @@
 <file path=ppt/slides/slide12.xml><?xml version="1.0" encoding="utf-8"?>
 <p:sld xmlns:a="http://schemas.openxmlformats.org/drawingml/2006/main" xmlns:r="http://schemas.openxmlformats.org/officeDocument/2006/relationships" xmlns:p="http://schemas.openxmlformats.org/presentationml/2006/main">
   <p:cSld name="Slide 12">
+    <p:bg>
+      <p:bgPr>
+        <a:solidFill>
+          <a:srgbClr val="FFFFFF"/>
+        </a:solidFill>
+      </p:bgPr>
+    </p:bg>
+    <p:spTree>
+      <p:nvGrpSpPr>
+        <p:cNvPr id="1" name=""/>
+        <p:cNvGrpSpPr/>
+        <p:nvPr/>
+      </p:nvGrpSpPr>
+      <p:grpSpPr>
+        <a:xfrm>
+          <a:off x="0" y="0"/>
+          <a:ext cx="0" cy="0"/>
+          <a:chOff x="0" y="0"/>
+          <a:chExt cx="0" cy="0"/>
+        </a:xfrm>
+      </p:grpSpPr>
+      <p:sp>
+        <p:nvSpPr>
+          <p:cNvPr id="2" name="Text 0"/>
+          <p:cNvSpPr/>
+          <p:nvPr/>
+        </p:nvSpPr>
+        <p:spPr>
+          <a:xfrm>
+            <a:off x="640080" y="502920"/>
+            <a:ext cx="10972800" cy="274320"/>
+          </a:xfrm>
+          <a:prstGeom prst="rect">
+            <a:avLst/>
+          </a:prstGeom>
+          <a:noFill/>
+          <a:ln/>
+        </p:spPr>
+        <p:txBody>
+          <a:bodyPr wrap="square" lIns="0" tIns="0" rIns="0" bIns="0" rtlCol="0" anchor="ctr"/>
+          <a:lstStyle/>
+          <a:p>
+            <a:pPr indent="0" marL="0">
+              <a:buNone/>
+            </a:pPr>
+            <a:r>
+              <a:rPr lang="en-US" sz="1200" b="1" spc="300" kern="0" dirty="0">
+                <a:solidFill>
+                  <a:srgbClr val="12A47E"/>
+                </a:solidFill>
+                <a:latin typeface="Calibri" pitchFamily="34" charset="0"/>
+                <a:ea typeface="Calibri" pitchFamily="34" charset="-122"/>
+                <a:cs typeface="Calibri" pitchFamily="34" charset="-120"/>
+              </a:rPr>
+              <a:t>BACKLOG-HEALTH DASHBOARD</a:t>
+            </a:r>
+            <a:endParaRPr lang="en-US" sz="1200" dirty="0"/>
+          </a:p>
+        </p:txBody>
+      </p:sp>
+      <p:sp>
+        <p:nvSpPr>
+          <p:cNvPr id="3" name="Text 1"/>
+          <p:cNvSpPr/>
+          <p:nvPr/>
+        </p:nvSpPr>
+        <p:spPr>
+          <a:xfrm>
+            <a:off x="640080" y="777240"/>
+            <a:ext cx="10972800" cy="777240"/>
+          </a:xfrm>
+          <a:prstGeom prst="rect">
+            <a:avLst/>
+          </a:prstGeom>
+          <a:noFill/>
+          <a:ln/>
+        </p:spPr>
+        <p:txBody>
+          <a:bodyPr wrap="square" lIns="0" tIns="0" rIns="0" bIns="0" rtlCol="0" anchor="ctr"/>
+          <a:lstStyle/>
+          <a:p>
+            <a:pPr indent="0" marL="0">
+              <a:buNone/>
+            </a:pPr>
+            <a:r>
+              <a:rPr lang="en-US" sz="3200" b="1" dirty="0">
+                <a:solidFill>
+                  <a:srgbClr val="0F6E56"/>
+                </a:solidFill>
+                <a:latin typeface="Cambria" pitchFamily="34" charset="0"/>
+                <a:ea typeface="Cambria" pitchFamily="34" charset="-122"/>
+                <a:cs typeface="Cambria" pitchFamily="34" charset="-120"/>
+              </a:rPr>
+              <a:t>From workflow tool to health instrument</a:t>
+            </a:r>
+            <a:endParaRPr lang="en-US" sz="3200" dirty="0"/>
+          </a:p>
+        </p:txBody>
+      </p:sp>
+      <p:pic>
+        <p:nvPicPr>
+          <p:cNvPr id="4" name="Image 0" descr="/home/claude/agile-governance/dashboard/screenshot.png">    </p:cNvPr>
+          <p:cNvPicPr>
+            <a:picLocks noChangeAspect="1"/>
+          </p:cNvPicPr>
+          <p:nvPr/>
+        </p:nvPicPr>
+        <p:blipFill>
+          <a:blip r:embed="rId1"/>
+          <a:srcRect l="0" r="0" t="0" b="0"/>
+          <a:stretch/>
+        </p:blipFill>
+        <p:spPr>
+          <a:xfrm>
+            <a:off x="640080" y="1874520"/>
+            <a:ext cx="7360920" cy="4343400"/>
+          </a:xfrm>
+          <a:prstGeom prst="rect">
+            <a:avLst/>
+          </a:prstGeom>
+        </p:spPr>
+      </p:pic>
+      <p:sp>
+        <p:nvSpPr>
+          <p:cNvPr id="5" name="Shape 2"/>
+          <p:cNvSpPr/>
+          <p:nvPr/>
+        </p:nvSpPr>
+        <p:spPr>
+          <a:xfrm>
+            <a:off x="8229600" y="1965960"/>
+            <a:ext cx="3291840" cy="914400"/>
+          </a:xfrm>
+          <a:prstGeom prst="roundRect">
+            <a:avLst>
+              <a:gd name="adj" fmla="val 10000"/>
+            </a:avLst>
+          </a:prstGeom>
+          <a:solidFill>
+            <a:srgbClr val="F0F7F5"/>
+          </a:solidFill>
+          <a:ln/>
+          <a:effectLst>
+            <a:outerShdw sx="100000" sy="100000" kx="0" ky="0" algn="bl" rotWithShape="0" blurRad="114300" dist="38100" dir="5400000">
+              <a:srgbClr val="0B3B36">
+                <a:alpha val="12000"/>
+              </a:srgbClr>
+            </a:outerShdw>
+          </a:effectLst>
+        </p:spPr>
+      </p:sp>
+      <p:sp>
+        <p:nvSpPr>
+          <p:cNvPr id="6" name="Text 3"/>
+          <p:cNvSpPr/>
+          <p:nvPr/>
+        </p:nvSpPr>
+        <p:spPr>
+          <a:xfrm>
+            <a:off x="8458200" y="2103120"/>
+            <a:ext cx="2926080" cy="365760"/>
+          </a:xfrm>
+          <a:prstGeom prst="rect">
+            <a:avLst/>
+          </a:prstGeom>
+          <a:noFill/>
+          <a:ln/>
+        </p:spPr>
+        <p:txBody>
+          <a:bodyPr wrap="square" lIns="0" tIns="0" rIns="0" bIns="0" rtlCol="0" anchor="ctr"/>
+          <a:lstStyle/>
+          <a:p>
+            <a:pPr indent="0" marL="0">
+              <a:buNone/>
+            </a:pPr>
+            <a:r>
+              <a:rPr lang="en-US" sz="1400" b="1" dirty="0">
+                <a:solidFill>
+                  <a:srgbClr val="0F6E56"/>
+                </a:solidFill>
+                <a:latin typeface="Calibri" pitchFamily="34" charset="0"/>
+                <a:ea typeface="Calibri" pitchFamily="34" charset="-122"/>
+                <a:cs typeface="Calibri" pitchFamily="34" charset="-120"/>
+              </a:rPr>
+              <a:t>Gate pass-rate</a:t>
+            </a:r>
+            <a:endParaRPr lang="en-US" sz="1400" dirty="0"/>
+          </a:p>
+        </p:txBody>
+      </p:sp>
+      <p:sp>
+        <p:nvSpPr>
+          <p:cNvPr id="7" name="Text 4"/>
+          <p:cNvSpPr/>
+          <p:nvPr/>
+        </p:nvSpPr>
+        <p:spPr>
+          <a:xfrm>
+            <a:off x="8458200" y="2441448"/>
+            <a:ext cx="2926080" cy="365760"/>
+          </a:xfrm>
+          <a:prstGeom prst="rect">
+            <a:avLst/>
+          </a:prstGeom>
+          <a:noFill/>
+          <a:ln/>
+        </p:spPr>
+        <p:txBody>
+          <a:bodyPr wrap="square" lIns="0" tIns="0" rIns="0" bIns="0" rtlCol="0" anchor="ctr"/>
+          <a:lstStyle/>
+          <a:p>
+            <a:pPr indent="0" marL="0">
+              <a:buNone/>
+            </a:pPr>
+            <a:r>
+              <a:rPr lang="en-US" sz="1150" dirty="0">
+                <a:solidFill>
+                  <a:srgbClr val="5B6B68"/>
+                </a:solidFill>
+                <a:latin typeface="Calibri" pitchFamily="34" charset="0"/>
+                <a:ea typeface="Calibri" pitchFamily="34" charset="-122"/>
+                <a:cs typeface="Calibri" pitchFamily="34" charset="-120"/>
+              </a:rPr>
+              <a:t>is backlog quality trending up?</a:t>
+            </a:r>
+            <a:endParaRPr lang="en-US" sz="1150" dirty="0"/>
+          </a:p>
+        </p:txBody>
+      </p:sp>
+      <p:sp>
+        <p:nvSpPr>
+          <p:cNvPr id="8" name="Shape 5"/>
+          <p:cNvSpPr/>
+          <p:nvPr/>
+        </p:nvSpPr>
+        <p:spPr>
+          <a:xfrm>
+            <a:off x="8229600" y="3044952"/>
+            <a:ext cx="3291840" cy="914400"/>
+          </a:xfrm>
+          <a:prstGeom prst="roundRect">
+            <a:avLst>
+              <a:gd name="adj" fmla="val 10000"/>
+            </a:avLst>
+          </a:prstGeom>
+          <a:solidFill>
+            <a:srgbClr val="F0F7F5"/>
+          </a:solidFill>
+          <a:ln/>
+          <a:effectLst>
+            <a:outerShdw sx="100000" sy="100000" kx="0" ky="0" algn="bl" rotWithShape="0" blurRad="114300" dist="38100" dir="5400000">
+              <a:srgbClr val="0B3B36">
+                <a:alpha val="12000"/>
+              </a:srgbClr>
+            </a:outerShdw>
+          </a:effectLst>
+        </p:spPr>
+      </p:sp>
+      <p:sp>
+        <p:nvSpPr>
+          <p:cNvPr id="9" name="Text 6"/>
+          <p:cNvSpPr/>
+          <p:nvPr/>
+        </p:nvSpPr>
+        <p:spPr>
+          <a:xfrm>
+            <a:off x="8458200" y="3182112"/>
+            <a:ext cx="2926080" cy="365760"/>
+          </a:xfrm>
+          <a:prstGeom prst="rect">
+            <a:avLst/>
+          </a:prstGeom>
+          <a:noFill/>
+          <a:ln/>
+        </p:spPr>
+        <p:txBody>
+          <a:bodyPr wrap="square" lIns="0" tIns="0" rIns="0" bIns="0" rtlCol="0" anchor="ctr"/>
+          <a:lstStyle/>
+          <a:p>
+            <a:pPr indent="0" marL="0">
+              <a:buNone/>
+            </a:pPr>
+            <a:r>
+              <a:rPr lang="en-US" sz="1400" b="1" dirty="0">
+                <a:solidFill>
+                  <a:srgbClr val="0F6E56"/>
+                </a:solidFill>
+                <a:latin typeface="Calibri" pitchFamily="34" charset="0"/>
+                <a:ea typeface="Calibri" pitchFamily="34" charset="-122"/>
+                <a:cs typeface="Calibri" pitchFamily="34" charset="-120"/>
+              </a:rPr>
+              <a:t>Recurring INVEST failures</a:t>
+            </a:r>
+            <a:endParaRPr lang="en-US" sz="1400" dirty="0"/>
+          </a:p>
+        </p:txBody>
+      </p:sp>
+      <p:sp>
+        <p:nvSpPr>
+          <p:cNvPr id="10" name="Text 7"/>
+          <p:cNvSpPr/>
+          <p:nvPr/>
+        </p:nvSpPr>
+        <p:spPr>
+          <a:xfrm>
+            <a:off x="8458200" y="3520440"/>
+            <a:ext cx="2926080" cy="365760"/>
+          </a:xfrm>
+          <a:prstGeom prst="rect">
+            <a:avLst/>
+          </a:prstGeom>
+          <a:noFill/>
+          <a:ln/>
+        </p:spPr>
+        <p:txBody>
+          <a:bodyPr wrap="square" lIns="0" tIns="0" rIns="0" bIns="0" rtlCol="0" anchor="ctr"/>
+          <a:lstStyle/>
+          <a:p>
+            <a:pPr indent="0" marL="0">
+              <a:buNone/>
+            </a:pPr>
+            <a:r>
+              <a:rPr lang="en-US" sz="1150" dirty="0">
+                <a:solidFill>
+                  <a:srgbClr val="5B6B68"/>
+                </a:solidFill>
+                <a:latin typeface="Calibri" pitchFamily="34" charset="0"/>
+                <a:ea typeface="Calibri" pitchFamily="34" charset="-122"/>
+                <a:cs typeface="Calibri" pitchFamily="34" charset="-120"/>
+              </a:rPr>
+              <a:t>which dimension to coach</a:t>
+            </a:r>
+            <a:endParaRPr lang="en-US" sz="1150" dirty="0"/>
+          </a:p>
+        </p:txBody>
+      </p:sp>
+      <p:sp>
+        <p:nvSpPr>
+          <p:cNvPr id="11" name="Shape 8"/>
+          <p:cNvSpPr/>
+          <p:nvPr/>
+        </p:nvSpPr>
+        <p:spPr>
+          <a:xfrm>
+            <a:off x="8229600" y="4123944"/>
+            <a:ext cx="3291840" cy="914400"/>
+          </a:xfrm>
+          <a:prstGeom prst="roundRect">
+            <a:avLst>
+              <a:gd name="adj" fmla="val 10000"/>
+            </a:avLst>
+          </a:prstGeom>
+          <a:solidFill>
+            <a:srgbClr val="F0F7F5"/>
+          </a:solidFill>
+          <a:ln/>
+          <a:effectLst>
+            <a:outerShdw sx="100000" sy="100000" kx="0" ky="0" algn="bl" rotWithShape="0" blurRad="114300" dist="38100" dir="5400000">
+              <a:srgbClr val="0B3B36">
+                <a:alpha val="12000"/>
+              </a:srgbClr>
+            </a:outerShdw>
+          </a:effectLst>
+        </p:spPr>
+      </p:sp>
+      <p:sp>
+        <p:nvSpPr>
+          <p:cNvPr id="12" name="Text 9"/>
+          <p:cNvSpPr/>
+          <p:nvPr/>
+        </p:nvSpPr>
+        <p:spPr>
+          <a:xfrm>
+            <a:off x="8458200" y="4261104"/>
+            <a:ext cx="2926080" cy="365760"/>
+          </a:xfrm>
+          <a:prstGeom prst="rect">
+            <a:avLst/>
+          </a:prstGeom>
+          <a:noFill/>
+          <a:ln/>
+        </p:spPr>
+        <p:txBody>
+          <a:bodyPr wrap="square" lIns="0" tIns="0" rIns="0" bIns="0" rtlCol="0" anchor="ctr"/>
+          <a:lstStyle/>
+          <a:p>
+            <a:pPr indent="0" marL="0">
+              <a:buNone/>
+            </a:pPr>
+            <a:r>
+              <a:rPr lang="en-US" sz="1400" b="1" dirty="0">
+                <a:solidFill>
+                  <a:srgbClr val="0F6E56"/>
+                </a:solidFill>
+                <a:latin typeface="Calibri" pitchFamily="34" charset="0"/>
+                <a:ea typeface="Calibri" pitchFamily="34" charset="-122"/>
+                <a:cs typeface="Calibri" pitchFamily="34" charset="-120"/>
+              </a:rPr>
+              <a:t>Top recurring issues</a:t>
+            </a:r>
+            <a:endParaRPr lang="en-US" sz="1400" dirty="0"/>
+          </a:p>
+        </p:txBody>
+      </p:sp>
+      <p:sp>
+        <p:nvSpPr>
+          <p:cNvPr id="13" name="Text 10"/>
+          <p:cNvSpPr/>
+          <p:nvPr/>
+        </p:nvSpPr>
+        <p:spPr>
+          <a:xfrm>
+            <a:off x="8458200" y="4599432"/>
+            <a:ext cx="2926080" cy="365760"/>
+          </a:xfrm>
+          <a:prstGeom prst="rect">
+            <a:avLst/>
+          </a:prstGeom>
+          <a:noFill/>
+          <a:ln/>
+        </p:spPr>
+        <p:txBody>
+          <a:bodyPr wrap="square" lIns="0" tIns="0" rIns="0" bIns="0" rtlCol="0" anchor="ctr"/>
+          <a:lstStyle/>
+          <a:p>
+            <a:pPr indent="0" marL="0">
+              <a:buNone/>
+            </a:pPr>
+            <a:r>
+              <a:rPr lang="en-US" sz="1150" dirty="0">
+                <a:solidFill>
+                  <a:srgbClr val="5B6B68"/>
+                </a:solidFill>
+                <a:latin typeface="Calibri" pitchFamily="34" charset="0"/>
+                <a:ea typeface="Calibri" pitchFamily="34" charset="-122"/>
+                <a:cs typeface="Calibri" pitchFamily="34" charset="-120"/>
+              </a:rPr>
+              <a:t>the backlog's common gaps</a:t>
+            </a:r>
+            <a:endParaRPr lang="en-US" sz="1150" dirty="0"/>
+          </a:p>
+        </p:txBody>
+      </p:sp>
+      <p:sp>
+        <p:nvSpPr>
+          <p:cNvPr id="14" name="Shape 11"/>
+          <p:cNvSpPr/>
+          <p:nvPr/>
+        </p:nvSpPr>
+        <p:spPr>
+          <a:xfrm>
+            <a:off x="8229600" y="5202936"/>
+            <a:ext cx="3291840" cy="914400"/>
+          </a:xfrm>
+          <a:prstGeom prst="roundRect">
+            <a:avLst>
+              <a:gd name="adj" fmla="val 10000"/>
+            </a:avLst>
+          </a:prstGeom>
+          <a:solidFill>
+            <a:srgbClr val="F0F7F5"/>
+          </a:solidFill>
+          <a:ln/>
+          <a:effectLst>
+            <a:outerShdw sx="100000" sy="100000" kx="0" ky="0" algn="bl" rotWithShape="0" blurRad="114300" dist="38100" dir="5400000">
+              <a:srgbClr val="0B3B36">
+                <a:alpha val="12000"/>
+              </a:srgbClr>
+            </a:outerShdw>
+          </a:effectLst>
+        </p:spPr>
+      </p:sp>
+      <p:sp>
+        <p:nvSpPr>
+          <p:cNvPr id="15" name="Text 12"/>
+          <p:cNvSpPr/>
+          <p:nvPr/>
+        </p:nvSpPr>
+        <p:spPr>
+          <a:xfrm>
+            <a:off x="8458200" y="5340096"/>
+            <a:ext cx="2926080" cy="365760"/>
+          </a:xfrm>
+          <a:prstGeom prst="rect">
+            <a:avLst/>
+          </a:prstGeom>
+          <a:noFill/>
+          <a:ln/>
+        </p:spPr>
+        <p:txBody>
+          <a:bodyPr wrap="square" lIns="0" tIns="0" rIns="0" bIns="0" rtlCol="0" anchor="ctr"/>
+          <a:lstStyle/>
+          <a:p>
+            <a:pPr indent="0" marL="0">
+              <a:buNone/>
+            </a:pPr>
+            <a:r>
+              <a:rPr lang="en-US" sz="1400" b="1" dirty="0">
+                <a:solidFill>
+                  <a:srgbClr val="0F6E56"/>
+                </a:solidFill>
+                <a:latin typeface="Calibri" pitchFamily="34" charset="0"/>
+                <a:ea typeface="Calibri" pitchFamily="34" charset="-122"/>
+                <a:cs typeface="Calibri" pitchFamily="34" charset="-120"/>
+              </a:rPr>
+              <a:t>Review queue + ageing</a:t>
+            </a:r>
+            <a:endParaRPr lang="en-US" sz="1400" dirty="0"/>
+          </a:p>
+        </p:txBody>
+      </p:sp>
+      <p:sp>
+        <p:nvSpPr>
+          <p:cNvPr id="16" name="Text 13"/>
+          <p:cNvSpPr/>
+          <p:nvPr/>
+        </p:nvSpPr>
+        <p:spPr>
+          <a:xfrm>
+            <a:off x="8458200" y="5678424"/>
+            <a:ext cx="2926080" cy="365760"/>
+          </a:xfrm>
+          <a:prstGeom prst="rect">
+            <a:avLst/>
+          </a:prstGeom>
+          <a:noFill/>
+          <a:ln/>
+        </p:spPr>
+        <p:txBody>
+          <a:bodyPr wrap="square" lIns="0" tIns="0" rIns="0" bIns="0" rtlCol="0" anchor="ctr"/>
+          <a:lstStyle/>
+          <a:p>
+            <a:pPr indent="0" marL="0">
+              <a:buNone/>
+            </a:pPr>
+            <a:r>
+              <a:rPr lang="en-US" sz="1150" dirty="0">
+                <a:solidFill>
+                  <a:srgbClr val="5B6B68"/>
+                </a:solidFill>
+                <a:latin typeface="Calibri" pitchFamily="34" charset="0"/>
+                <a:ea typeface="Calibri" pitchFamily="34" charset="-122"/>
+                <a:cs typeface="Calibri" pitchFamily="34" charset="-120"/>
+              </a:rPr>
+              <a:t>what's waiting on a human</a:t>
+            </a:r>
+            <a:endParaRPr lang="en-US" sz="1150" dirty="0"/>
+          </a:p>
+        </p:txBody>
+      </p:sp>
+    </p:spTree>
+  </p:cSld>
+  <p:clrMapOvr>
+    <a:masterClrMapping/>
+  </p:clrMapOvr>
+</p:sld>
+</file>
+
+<file path=ppt/slides/slide13.xml><?xml version="1.0" encoding="utf-8"?>
+<p:sld xmlns:a="http://schemas.openxmlformats.org/drawingml/2006/main" xmlns:r="http://schemas.openxmlformats.org/officeDocument/2006/relationships" xmlns:p="http://schemas.openxmlformats.org/presentationml/2006/main">
+  <p:cSld name="Slide 13">
+    <p:bg>
+      <p:bgPr>
+        <a:solidFill>
+          <a:srgbClr val="FFFFFF"/>
+        </a:solidFill>
+      </p:bgPr>
+    </p:bg>
+    <p:spTree>
+      <p:nvGrpSpPr>
+        <p:cNvPr id="1" name=""/>
+        <p:cNvGrpSpPr/>
+        <p:nvPr/>
+      </p:nvGrpSpPr>
+      <p:grpSpPr>
+        <a:xfrm>
+          <a:off x="0" y="0"/>
+          <a:ext cx="0" cy="0"/>
+          <a:chOff x="0" y="0"/>
+          <a:chExt cx="0" cy="0"/>
+        </a:xfrm>
+      </p:grpSpPr>
+      <p:sp>
+        <p:nvSpPr>
+          <p:cNvPr id="2" name="Text 0"/>
+          <p:cNvSpPr/>
+          <p:nvPr/>
+        </p:nvSpPr>
+        <p:spPr>
+          <a:xfrm>
+            <a:off x="640080" y="502920"/>
+            <a:ext cx="10972800" cy="274320"/>
+          </a:xfrm>
+          <a:prstGeom prst="rect">
+            <a:avLst/>
+          </a:prstGeom>
+          <a:noFill/>
+          <a:ln/>
+        </p:spPr>
+        <p:txBody>
+          <a:bodyPr wrap="square" lIns="0" tIns="0" rIns="0" bIns="0" rtlCol="0" anchor="ctr"/>
+          <a:lstStyle/>
+          <a:p>
+            <a:pPr indent="0" marL="0">
+              <a:buNone/>
+            </a:pPr>
+            <a:r>
+              <a:rPr lang="en-US" sz="1200" b="1" spc="300" kern="0" dirty="0">
+                <a:solidFill>
+                  <a:srgbClr val="12A47E"/>
+                </a:solidFill>
+                <a:latin typeface="Calibri" pitchFamily="34" charset="0"/>
+                <a:ea typeface="Calibri" pitchFamily="34" charset="-122"/>
+                <a:cs typeface="Calibri" pitchFamily="34" charset="-120"/>
+              </a:rPr>
+              <a:t>IMPACT</a:t>
+            </a:r>
+            <a:endParaRPr lang="en-US" sz="1200" dirty="0"/>
+          </a:p>
+        </p:txBody>
+      </p:sp>
+      <p:sp>
+        <p:nvSpPr>
+          <p:cNvPr id="3" name="Text 1"/>
+          <p:cNvSpPr/>
+          <p:nvPr/>
+        </p:nvSpPr>
+        <p:spPr>
+          <a:xfrm>
+            <a:off x="640080" y="777240"/>
+            <a:ext cx="10972800" cy="777240"/>
+          </a:xfrm>
+          <a:prstGeom prst="rect">
+            <a:avLst/>
+          </a:prstGeom>
+          <a:noFill/>
+          <a:ln/>
+        </p:spPr>
+        <p:txBody>
+          <a:bodyPr wrap="square" lIns="0" tIns="0" rIns="0" bIns="0" rtlCol="0" anchor="ctr"/>
+          <a:lstStyle/>
+          <a:p>
+            <a:pPr indent="0" marL="0">
+              <a:buNone/>
+            </a:pPr>
+            <a:r>
+              <a:rPr lang="en-US" sz="3200" b="1" dirty="0">
+                <a:solidFill>
+                  <a:srgbClr val="0F6E56"/>
+                </a:solidFill>
+                <a:latin typeface="Cambria" pitchFamily="34" charset="0"/>
+                <a:ea typeface="Cambria" pitchFamily="34" charset="-122"/>
+                <a:cs typeface="Cambria" pitchFamily="34" charset="-120"/>
+              </a:rPr>
+              <a:t>What this gives a team</a:t>
+            </a:r>
+            <a:endParaRPr lang="en-US" sz="3200" dirty="0"/>
+          </a:p>
+        </p:txBody>
+      </p:sp>
+      <p:sp>
+        <p:nvSpPr>
+          <p:cNvPr id="4" name="Shape 2"/>
+          <p:cNvSpPr/>
+          <p:nvPr/>
+        </p:nvSpPr>
+        <p:spPr>
+          <a:xfrm>
+            <a:off x="640080" y="2148840"/>
+            <a:ext cx="10881360" cy="1097280"/>
+          </a:xfrm>
+          <a:prstGeom prst="roundRect">
+            <a:avLst>
+              <a:gd name="adj" fmla="val 8333"/>
+            </a:avLst>
+          </a:prstGeom>
+          <a:solidFill>
+            <a:srgbClr val="F0F7F5"/>
+          </a:solidFill>
+          <a:ln/>
+          <a:effectLst>
+            <a:outerShdw sx="100000" sy="100000" kx="0" ky="0" algn="bl" rotWithShape="0" blurRad="114300" dist="38100" dir="5400000">
+              <a:srgbClr val="0B3B36">
+                <a:alpha val="12000"/>
+              </a:srgbClr>
+            </a:outerShdw>
+          </a:effectLst>
+        </p:spPr>
+      </p:sp>
+      <p:sp>
+        <p:nvSpPr>
+          <p:cNvPr id="5" name="Shape 3"/>
+          <p:cNvSpPr/>
+          <p:nvPr/>
+        </p:nvSpPr>
+        <p:spPr>
+          <a:xfrm>
+            <a:off x="960120" y="2441448"/>
+            <a:ext cx="512064" cy="512064"/>
+          </a:xfrm>
+          <a:prstGeom prst="ellipse">
+            <a:avLst/>
+          </a:prstGeom>
+          <a:solidFill>
+            <a:srgbClr val="12A47E"/>
+          </a:solidFill>
+          <a:ln/>
+        </p:spPr>
+      </p:sp>
+      <p:sp>
+        <p:nvSpPr>
+          <p:cNvPr id="6" name="Text 4"/>
+          <p:cNvSpPr/>
+          <p:nvPr/>
+        </p:nvSpPr>
+        <p:spPr>
+          <a:xfrm>
+            <a:off x="960120" y="2441448"/>
+            <a:ext cx="512064" cy="512064"/>
+          </a:xfrm>
+          <a:prstGeom prst="rect">
+            <a:avLst/>
+          </a:prstGeom>
+          <a:noFill/>
+          <a:ln/>
+        </p:spPr>
+        <p:txBody>
+          <a:bodyPr wrap="square" lIns="0" tIns="0" rIns="0" bIns="0" rtlCol="0" anchor="ctr"/>
+          <a:lstStyle/>
+          <a:p>
+            <a:pPr algn="ctr" indent="0" marL="0">
+              <a:buNone/>
+            </a:pPr>
+            <a:r>
+              <a:rPr lang="en-US" sz="1800" b="1" dirty="0">
+                <a:solidFill>
+                  <a:srgbClr val="FFFFFF"/>
+                </a:solidFill>
+                <a:latin typeface="Cambria" pitchFamily="34" charset="0"/>
+                <a:ea typeface="Cambria" pitchFamily="34" charset="-122"/>
+                <a:cs typeface="Cambria" pitchFamily="34" charset="-120"/>
+              </a:rPr>
+              <a:t>1</a:t>
+            </a:r>
+            <a:endParaRPr lang="en-US" sz="1800" dirty="0"/>
+          </a:p>
+        </p:txBody>
+      </p:sp>
+      <p:sp>
+        <p:nvSpPr>
+          <p:cNvPr id="7" name="Text 5"/>
+          <p:cNvSpPr/>
+          <p:nvPr/>
+        </p:nvSpPr>
+        <p:spPr>
+          <a:xfrm>
+            <a:off x="1737360" y="2350008"/>
+            <a:ext cx="9509760" cy="411480"/>
+          </a:xfrm>
+          <a:prstGeom prst="rect">
+            <a:avLst/>
+          </a:prstGeom>
+          <a:noFill/>
+          <a:ln/>
+        </p:spPr>
+        <p:txBody>
+          <a:bodyPr wrap="square" lIns="0" tIns="0" rIns="0" bIns="0" rtlCol="0" anchor="ctr"/>
+          <a:lstStyle/>
+          <a:p>
+            <a:pPr indent="0" marL="0">
+              <a:buNone/>
+            </a:pPr>
+            <a:r>
+              <a:rPr lang="en-US" sz="1900" b="1" dirty="0">
+                <a:solidFill>
+                  <a:srgbClr val="0F6E56"/>
+                </a:solidFill>
+                <a:latin typeface="Cambria" pitchFamily="34" charset="0"/>
+                <a:ea typeface="Cambria" pitchFamily="34" charset="-122"/>
+                <a:cs typeface="Cambria" pitchFamily="34" charset="-120"/>
+              </a:rPr>
+              <a:t>Faster, consistent planning</a:t>
+            </a:r>
+            <a:endParaRPr lang="en-US" sz="1900" dirty="0"/>
+          </a:p>
+        </p:txBody>
+      </p:sp>
+      <p:sp>
+        <p:nvSpPr>
+          <p:cNvPr id="8" name="Text 6"/>
+          <p:cNvSpPr/>
+          <p:nvPr/>
+        </p:nvSpPr>
+        <p:spPr>
+          <a:xfrm>
+            <a:off x="1737360" y="2752344"/>
+            <a:ext cx="9509760" cy="365760"/>
+          </a:xfrm>
+          <a:prstGeom prst="rect">
+            <a:avLst/>
+          </a:prstGeom>
+          <a:noFill/>
+          <a:ln/>
+        </p:spPr>
+        <p:txBody>
+          <a:bodyPr wrap="square" lIns="0" tIns="0" rIns="0" bIns="0" rtlCol="0" anchor="ctr"/>
+          <a:lstStyle/>
+          <a:p>
+            <a:pPr indent="0" marL="0">
+              <a:buNone/>
+            </a:pPr>
+            <a:r>
+              <a:rPr lang="en-US" sz="1450" dirty="0">
+                <a:solidFill>
+                  <a:srgbClr val="5B6B68"/>
+                </a:solidFill>
+                <a:latin typeface="Calibri" pitchFamily="34" charset="0"/>
+                <a:ea typeface="Calibri" pitchFamily="34" charset="-122"/>
+                <a:cs typeface="Calibri" pitchFamily="34" charset="-120"/>
+              </a:rPr>
+              <a:t>Weak stories are filtered before they reach the board.</a:t>
+            </a:r>
+            <a:endParaRPr lang="en-US" sz="1450" dirty="0"/>
+          </a:p>
+        </p:txBody>
+      </p:sp>
+      <p:sp>
+        <p:nvSpPr>
+          <p:cNvPr id="9" name="Shape 7"/>
+          <p:cNvSpPr/>
+          <p:nvPr/>
+        </p:nvSpPr>
+        <p:spPr>
+          <a:xfrm>
+            <a:off x="640080" y="3429000"/>
+            <a:ext cx="10881360" cy="1097280"/>
+          </a:xfrm>
+          <a:prstGeom prst="roundRect">
+            <a:avLst>
+              <a:gd name="adj" fmla="val 8333"/>
+            </a:avLst>
+          </a:prstGeom>
+          <a:solidFill>
+            <a:srgbClr val="F0F7F5"/>
+          </a:solidFill>
+          <a:ln/>
+          <a:effectLst>
+            <a:outerShdw sx="100000" sy="100000" kx="0" ky="0" algn="bl" rotWithShape="0" blurRad="114300" dist="38100" dir="5400000">
+              <a:srgbClr val="0B3B36">
+                <a:alpha val="12000"/>
+              </a:srgbClr>
+            </a:outerShdw>
+          </a:effectLst>
+        </p:spPr>
+      </p:sp>
+      <p:sp>
+        <p:nvSpPr>
+          <p:cNvPr id="10" name="Shape 8"/>
+          <p:cNvSpPr/>
+          <p:nvPr/>
+        </p:nvSpPr>
+        <p:spPr>
+          <a:xfrm>
+            <a:off x="960120" y="3721608"/>
+            <a:ext cx="512064" cy="512064"/>
+          </a:xfrm>
+          <a:prstGeom prst="ellipse">
+            <a:avLst/>
+          </a:prstGeom>
+          <a:solidFill>
+            <a:srgbClr val="12A47E"/>
+          </a:solidFill>
+          <a:ln/>
+        </p:spPr>
+      </p:sp>
+      <p:sp>
+        <p:nvSpPr>
+          <p:cNvPr id="11" name="Text 9"/>
+          <p:cNvSpPr/>
+          <p:nvPr/>
+        </p:nvSpPr>
+        <p:spPr>
+          <a:xfrm>
+            <a:off x="960120" y="3721608"/>
+            <a:ext cx="512064" cy="512064"/>
+          </a:xfrm>
+          <a:prstGeom prst="rect">
+            <a:avLst/>
+          </a:prstGeom>
+          <a:noFill/>
+          <a:ln/>
+        </p:spPr>
+        <p:txBody>
+          <a:bodyPr wrap="square" lIns="0" tIns="0" rIns="0" bIns="0" rtlCol="0" anchor="ctr"/>
+          <a:lstStyle/>
+          <a:p>
+            <a:pPr algn="ctr" indent="0" marL="0">
+              <a:buNone/>
+            </a:pPr>
+            <a:r>
+              <a:rPr lang="en-US" sz="1800" b="1" dirty="0">
+                <a:solidFill>
+                  <a:srgbClr val="FFFFFF"/>
+                </a:solidFill>
+                <a:latin typeface="Cambria" pitchFamily="34" charset="0"/>
+                <a:ea typeface="Cambria" pitchFamily="34" charset="-122"/>
+                <a:cs typeface="Cambria" pitchFamily="34" charset="-120"/>
+              </a:rPr>
+              <a:t>2</a:t>
+            </a:r>
+            <a:endParaRPr lang="en-US" sz="1800" dirty="0"/>
+          </a:p>
+        </p:txBody>
+      </p:sp>
+      <p:sp>
+        <p:nvSpPr>
+          <p:cNvPr id="12" name="Text 10"/>
+          <p:cNvSpPr/>
+          <p:nvPr/>
+        </p:nvSpPr>
+        <p:spPr>
+          <a:xfrm>
+            <a:off x="1737360" y="3630168"/>
+            <a:ext cx="9509760" cy="411480"/>
+          </a:xfrm>
+          <a:prstGeom prst="rect">
+            <a:avLst/>
+          </a:prstGeom>
+          <a:noFill/>
+          <a:ln/>
+        </p:spPr>
+        <p:txBody>
+          <a:bodyPr wrap="square" lIns="0" tIns="0" rIns="0" bIns="0" rtlCol="0" anchor="ctr"/>
+          <a:lstStyle/>
+          <a:p>
+            <a:pPr indent="0" marL="0">
+              <a:buNone/>
+            </a:pPr>
+            <a:r>
+              <a:rPr lang="en-US" sz="1900" b="1" dirty="0">
+                <a:solidFill>
+                  <a:srgbClr val="0F6E56"/>
+                </a:solidFill>
+                <a:latin typeface="Cambria" pitchFamily="34" charset="0"/>
+                <a:ea typeface="Cambria" pitchFamily="34" charset="-122"/>
+                <a:cs typeface="Cambria" pitchFamily="34" charset="-120"/>
+              </a:rPr>
+              <a:t>A measurable quality gate</a:t>
+            </a:r>
+            <a:endParaRPr lang="en-US" sz="1900" dirty="0"/>
+          </a:p>
+        </p:txBody>
+      </p:sp>
+      <p:sp>
+        <p:nvSpPr>
+          <p:cNvPr id="13" name="Text 11"/>
+          <p:cNvSpPr/>
+          <p:nvPr/>
+        </p:nvSpPr>
+        <p:spPr>
+          <a:xfrm>
+            <a:off x="1737360" y="4032504"/>
+            <a:ext cx="9509760" cy="365760"/>
+          </a:xfrm>
+          <a:prstGeom prst="rect">
+            <a:avLst/>
+          </a:prstGeom>
+          <a:noFill/>
+          <a:ln/>
+        </p:spPr>
+        <p:txBody>
+          <a:bodyPr wrap="square" lIns="0" tIns="0" rIns="0" bIns="0" rtlCol="0" anchor="ctr"/>
+          <a:lstStyle/>
+          <a:p>
+            <a:pPr indent="0" marL="0">
+              <a:buNone/>
+            </a:pPr>
+            <a:r>
+              <a:rPr lang="en-US" sz="1450" dirty="0">
+                <a:solidFill>
+                  <a:srgbClr val="5B6B68"/>
+                </a:solidFill>
+                <a:latin typeface="Calibri" pitchFamily="34" charset="0"/>
+                <a:ea typeface="Calibri" pitchFamily="34" charset="-122"/>
+                <a:cs typeface="Calibri" pitchFamily="34" charset="-120"/>
+              </a:rPr>
+              <a:t>Pass-rate is a backlog-health KPI, not a subjective call.</a:t>
+            </a:r>
+            <a:endParaRPr lang="en-US" sz="1450" dirty="0"/>
+          </a:p>
+        </p:txBody>
+      </p:sp>
+      <p:sp>
+        <p:nvSpPr>
+          <p:cNvPr id="14" name="Shape 12"/>
+          <p:cNvSpPr/>
+          <p:nvPr/>
+        </p:nvSpPr>
+        <p:spPr>
+          <a:xfrm>
+            <a:off x="640080" y="4709160"/>
+            <a:ext cx="10881360" cy="1097280"/>
+          </a:xfrm>
+          <a:prstGeom prst="roundRect">
+            <a:avLst>
+              <a:gd name="adj" fmla="val 8333"/>
+            </a:avLst>
+          </a:prstGeom>
+          <a:solidFill>
+            <a:srgbClr val="F0F7F5"/>
+          </a:solidFill>
+          <a:ln/>
+          <a:effectLst>
+            <a:outerShdw sx="100000" sy="100000" kx="0" ky="0" algn="bl" rotWithShape="0" blurRad="114300" dist="38100" dir="5400000">
+              <a:srgbClr val="0B3B36">
+                <a:alpha val="12000"/>
+              </a:srgbClr>
+            </a:outerShdw>
+          </a:effectLst>
+        </p:spPr>
+      </p:sp>
+      <p:sp>
+        <p:nvSpPr>
+          <p:cNvPr id="15" name="Shape 13"/>
+          <p:cNvSpPr/>
+          <p:nvPr/>
+        </p:nvSpPr>
+        <p:spPr>
+          <a:xfrm>
+            <a:off x="960120" y="5001768"/>
+            <a:ext cx="512064" cy="512064"/>
+          </a:xfrm>
+          <a:prstGeom prst="ellipse">
+            <a:avLst/>
+          </a:prstGeom>
+          <a:solidFill>
+            <a:srgbClr val="0F6E56"/>
+          </a:solidFill>
+          <a:ln/>
+        </p:spPr>
+      </p:sp>
+      <p:sp>
+        <p:nvSpPr>
+          <p:cNvPr id="16" name="Text 14"/>
+          <p:cNvSpPr/>
+          <p:nvPr/>
+        </p:nvSpPr>
+        <p:spPr>
+          <a:xfrm>
+            <a:off x="960120" y="5001768"/>
+            <a:ext cx="512064" cy="512064"/>
+          </a:xfrm>
+          <a:prstGeom prst="rect">
+            <a:avLst/>
+          </a:prstGeom>
+          <a:noFill/>
+          <a:ln/>
+        </p:spPr>
+        <p:txBody>
+          <a:bodyPr wrap="square" lIns="0" tIns="0" rIns="0" bIns="0" rtlCol="0" anchor="ctr"/>
+          <a:lstStyle/>
+          <a:p>
+            <a:pPr algn="ctr" indent="0" marL="0">
+              <a:buNone/>
+            </a:pPr>
+            <a:r>
+              <a:rPr lang="en-US" sz="1800" b="1" dirty="0">
+                <a:solidFill>
+                  <a:srgbClr val="FFFFFF"/>
+                </a:solidFill>
+                <a:latin typeface="Cambria" pitchFamily="34" charset="0"/>
+                <a:ea typeface="Cambria" pitchFamily="34" charset="-122"/>
+                <a:cs typeface="Cambria" pitchFamily="34" charset="-120"/>
+              </a:rPr>
+              <a:t>3</a:t>
+            </a:r>
+            <a:endParaRPr lang="en-US" sz="1800" dirty="0"/>
+          </a:p>
+        </p:txBody>
+      </p:sp>
+      <p:sp>
+        <p:nvSpPr>
+          <p:cNvPr id="17" name="Text 15"/>
+          <p:cNvSpPr/>
+          <p:nvPr/>
+        </p:nvSpPr>
+        <p:spPr>
+          <a:xfrm>
+            <a:off x="1737360" y="4910328"/>
+            <a:ext cx="9509760" cy="411480"/>
+          </a:xfrm>
+          <a:prstGeom prst="rect">
+            <a:avLst/>
+          </a:prstGeom>
+          <a:noFill/>
+          <a:ln/>
+        </p:spPr>
+        <p:txBody>
+          <a:bodyPr wrap="square" lIns="0" tIns="0" rIns="0" bIns="0" rtlCol="0" anchor="ctr"/>
+          <a:lstStyle/>
+          <a:p>
+            <a:pPr indent="0" marL="0">
+              <a:buNone/>
+            </a:pPr>
+            <a:r>
+              <a:rPr lang="en-US" sz="1900" b="1" dirty="0">
+                <a:solidFill>
+                  <a:srgbClr val="0F6E56"/>
+                </a:solidFill>
+                <a:latin typeface="Cambria" pitchFamily="34" charset="0"/>
+                <a:ea typeface="Cambria" pitchFamily="34" charset="-122"/>
+                <a:cs typeface="Cambria" pitchFamily="34" charset="-120"/>
+              </a:rPr>
+              <a:t>Itself governed</a:t>
+            </a:r>
+            <a:endParaRPr lang="en-US" sz="1900" dirty="0"/>
+          </a:p>
+        </p:txBody>
+      </p:sp>
+      <p:sp>
+        <p:nvSpPr>
+          <p:cNvPr id="18" name="Text 16"/>
+          <p:cNvSpPr/>
+          <p:nvPr/>
+        </p:nvSpPr>
+        <p:spPr>
+          <a:xfrm>
+            <a:off x="1737360" y="5312664"/>
+            <a:ext cx="9509760" cy="365760"/>
+          </a:xfrm>
+          <a:prstGeom prst="rect">
+            <a:avLst/>
+          </a:prstGeom>
+          <a:noFill/>
+          <a:ln/>
+        </p:spPr>
+        <p:txBody>
+          <a:bodyPr wrap="square" lIns="0" tIns="0" rIns="0" bIns="0" rtlCol="0" anchor="ctr"/>
+          <a:lstStyle/>
+          <a:p>
+            <a:pPr indent="0" marL="0">
+              <a:buNone/>
+            </a:pPr>
+            <a:r>
+              <a:rPr lang="en-US" sz="1450" dirty="0">
+                <a:solidFill>
+                  <a:srgbClr val="5B6B68"/>
+                </a:solidFill>
+                <a:latin typeface="Calibri" pitchFamily="34" charset="0"/>
+                <a:ea typeface="Calibri" pitchFamily="34" charset="-122"/>
+                <a:cs typeface="Calibri" pitchFamily="34" charset="-120"/>
+              </a:rPr>
+              <a:t>Every decision is traced; every agent is evaluated.</a:t>
+            </a:r>
+            <a:endParaRPr lang="en-US" sz="1450" dirty="0"/>
+          </a:p>
+        </p:txBody>
+      </p:sp>
+    </p:spTree>
+  </p:cSld>
+  <p:clrMapOvr>
+    <a:masterClrMapping/>
+  </p:clrMapOvr>
+</p:sld>
+</file>
+
+<file path=ppt/slides/slide14.xml><?xml version="1.0" encoding="utf-8"?>
+<p:sld xmlns:a="http://schemas.openxmlformats.org/drawingml/2006/main" xmlns:r="http://schemas.openxmlformats.org/officeDocument/2006/relationships" xmlns:p="http://schemas.openxmlformats.org/presentationml/2006/main">
+  <p:cSld name="Slide 14">
     <p:bg>
       <p:bgPr>
         <a:solidFill>

</xml_diff>